<commit_message>
deck: embed 12 real result figures -> presentation-ready (20 slides)
build_deck.py now places each experiment's committed PNGs (forecast, return-levels,
interaction network, hard-mode CNN>RF bars, change map, champion progress, hydrograph,
conformal coverage) in a right-column layout; added hydrology + conformal-UQ slides.
Aspect-preserved, graceful skip on missing paths, theme/notes intact. Only real numbers.

Co-Authored-By: Claude Opus 4.7 (1M context) <noreply@anthropic.com>
</commit_message>
<xml_diff>
--- a/docs/talk/deck.pptx
+++ b/docs/talk/deck.pptx
@@ -23,6 +23,8 @@
     <p:sldId id="271" r:id="rId23"/>
     <p:sldId id="272" r:id="rId24"/>
     <p:sldId id="273" r:id="rId25"/>
+    <p:sldId id="274" r:id="rId26"/>
+    <p:sldId id="275" r:id="rId27"/>
   </p:sldIdLst>
   <p:sldSz cx="12191695" cy="6858000" type="screen4x3"/>
   <p:notesSz cx="6858000" cy="9144000"/>
@@ -729,7 +731,7 @@
           <a:lstStyle/>
           <a:p>
             <a:r>
-              <a:t>Now the flagship: an autonomous, gated research loop running unattended on a single 4090.</a:t>
+              <a:t>Hydrology is the cell where AFTER cleanly wins on the science, not just on speed. A linear or conceptual bucket model can't carry the catchment's memory — soil moisture, snowpack, routing — so it tops out around an NSE of 0.14 here. An LSTM rainfall-runoff model carries that state and reaches 0.70, a +0.56 NSE gain, which is the well-documented LSTM-hydrology result from the literature reproduced in one command. The gap widens with more data, and every number here is committed in RESULTS.md.</a:t>
             </a:r>
           </a:p>
         </p:txBody>
@@ -799,7 +801,7 @@
           <a:lstStyle/>
           <a:p>
             <a:r>
-              <a:t>This is the part that feels like science fiction but isn't. The autoresearch loop turns Claude Code into the researcher: it diagnoses the current best model, cites prior work, forms a hypothesis, predicts the outcome, runs exactly one experiment, analyzes it, and checkpoints. Two gates matter for this audience — it cannot run an experiment until its citations and its reasoning pass a completeness check, which is the machine-enforced version of "don't fish." It produces a champion archive and a human-readable journal you can audit afterward.</a:t>
+              <a:t>Uncertainty is mandatory for this audience, so this experiment asks a blunt question: do our prediction intervals actually cover at the rate we claim? Normal-theory intervals look fine on paper but, under heavy tails, an 80% interval here covers 86.9% — miscalibrated, and the over-coverage hides bands that are the wrong width. Split conformal prediction gives distribution-free finite-sample coverage: the mean gap drops from 0.033 to 0.004, roughly seven times tighter, and the bands get narrower too. It's both a calibration and a sharpness win, committed in RESULTS.md.</a:t>
             </a:r>
           </a:p>
         </p:txBody>
@@ -869,7 +871,7 @@
           <a:lstStyle/>
           <a:p>
             <a:r>
-              <a:t>Let me be careful here, because over-claiming would lose this room. The loop is excellent at exhaustively and transparently searching a space you define and archiving what wins. It does not pick the question, the loss function, or the standard of validity — that is your job, and the system is designed to keep it your job, including a fingerprint that flags if the objective quietly drifts mid-run. Treat its output as a well-documented draft to review, never as an oracle.</a:t>
+              <a:t>Now the flagship: an autonomous, gated research loop running unattended on a single 4090.</a:t>
             </a:r>
           </a:p>
         </p:txBody>
@@ -939,7 +941,7 @@
           <a:lstStyle/>
           <a:p>
             <a:r>
-              <a:t>Here are the failure modes I worry about, and how this setup defends against each. Leakage is the big one, so splits are chronological or spatial by construction. Multiplicity is corrected explicitly when we scan many units. Uncertainty is reported as intervals, never bare point estimates. And because LLMs can fabricate references, anything not independently verified is quarantined and never stated as fact — that discipline is why I keep saying "see RESULTS.md" instead of quoting numbers from memory.</a:t>
+              <a:t>This is the part that feels like science fiction but isn't. The autoresearch loop turns Claude Code into the researcher: it diagnoses the current best model, cites prior work, forms a hypothesis, predicts the outcome, runs exactly one experiment, analyzes it, and checkpoints. Two gates matter for this audience — it cannot run an experiment until its citations and its reasoning pass a completeness check, which is the machine-enforced version of "don't fish." It produces a champion archive and a human-readable journal you can audit afterward.</a:t>
             </a:r>
           </a:p>
         </p:txBody>
@@ -1009,7 +1011,7 @@
           <a:lstStyle/>
           <a:p>
             <a:r>
-              <a:t>Concrete next steps, because I want you to leave with momentum. Today, just install the agent and ask it to redraw one figure from your most recent paper — low stakes, instant intuition. This week, give it a whole small pipeline end to end. This month, encode your group's validation rules as a reusable skill so the agent inherits your standards. Start on synthetic or small public data so nothing blocks you, then scale to real data and the GPU.</a:t>
+              <a:t>Let me be careful here, because over-claiming would lose this room. The loop is excellent at exhaustively and transparently searching a space you define and archiving what wins. It does not pick the question, the loss function, or the standard of validity — that is your job, and the system is designed to keep it your job, including a fingerprint that flags if the objective quietly drifts mid-run. Treat its output as a well-documented draft to review, never as an oracle.</a:t>
             </a:r>
           </a:p>
         </p:txBody>
@@ -1079,7 +1081,7 @@
           <a:lstStyle/>
           <a:p>
             <a:r>
-              <a:t>Zoom out. If labor stops being the constraint, then judgment becomes the differentiator — and judgment is what statistical training produces. I think the near future is each of us orchestrating a handful of agents across the taxonomy, with better audit trails than we have today because everything is logged and reproducible. The role doesn't shrink; it moves up the stack to the parts that were always the science.</a:t>
+              <a:t>Here are the failure modes I worry about, and how this setup defends against each. Leakage is the big one, so splits are chronological or spatial by construction. Multiplicity is corrected explicitly when we scan many units. Uncertainty is reported as intervals, never bare point estimates. And because LLMs can fabricate references, anything not independently verified is quarantined and never stated as fact — that discipline is why I keep saying "see RESULTS.md" instead of quoting numbers from memory.</a:t>
             </a:r>
           </a:p>
         </p:txBody>
@@ -1149,7 +1151,77 @@
           <a:lstStyle/>
           <a:p>
             <a:r>
-              <a:t>Thank you. Everything I showed lives in the companion repo, including this deck and a one-page handout with copy-paste prompts you can try tonight. The whole thing is reproducible: python run_all_tests.py runs the tests, and each experiment's run_before_after.py regenerates its committed results. The papers on this slide are the verifiable anchors I built on — arXiv IDs so you can check them yourself — and the datasets are the standard open sources in our field. I'm happy to take questions, and I'm especially interested in where you think the human-in-the-loop checks need to be stronger.</a:t>
+              <a:t>Concrete next steps, because I want you to leave with momentum. Today, just install the agent and ask it to redraw one figure from your most recent paper — low stakes, instant intuition. This week, give it a whole small pipeline end to end. This month, encode your group's validation rules as a reusable skill so the agent inherits your standards. Start on synthetic or small public data so nothing blocks you, then scale to real data and the GPU.</a:t>
+            </a:r>
+          </a:p>
+        </p:txBody>
+      </p:sp>
+      <p:sp>
+        <p:nvSpPr>
+          <p:cNvPr id="4" name="Slide Number Placeholder 3"/>
+          <p:cNvSpPr>
+            <a:spLocks noGrp="1"/>
+          </p:cNvSpPr>
+          <p:nvPr>
+            <p:ph type="sldNum" idx="5" sz="quarter"/>
+          </p:nvPr>
+        </p:nvSpPr>
+        <p:spPr/>
+      </p:sp>
+    </p:spTree>
+  </p:cSld>
+  <p:clrMapOvr>
+    <a:masterClrMapping/>
+  </p:clrMapOvr>
+</p:notes>
+</file>
+
+<file path=ppt/notesSlides/notesSlide19.xml><?xml version="1.0" encoding="utf-8"?>
+<p:notes xmlns:a="http://schemas.openxmlformats.org/drawingml/2006/main" xmlns:p="http://schemas.openxmlformats.org/presentationml/2006/main" xmlns:r="http://schemas.openxmlformats.org/officeDocument/2006/relationships">
+  <p:cSld>
+    <p:spTree>
+      <p:nvGrpSpPr>
+        <p:cNvPr id="1" name=""/>
+        <p:cNvGrpSpPr/>
+        <p:nvPr/>
+      </p:nvGrpSpPr>
+      <p:grpSpPr>
+        <a:xfrm>
+          <a:off x="0" y="0"/>
+          <a:ext cx="0" cy="0"/>
+          <a:chOff x="0" y="0"/>
+          <a:chExt cx="0" cy="0"/>
+        </a:xfrm>
+      </p:grpSpPr>
+      <p:sp>
+        <p:nvSpPr>
+          <p:cNvPr id="2" name="Slide Image Placeholder 1"/>
+          <p:cNvSpPr>
+            <a:spLocks noGrp="1"/>
+          </p:cNvSpPr>
+          <p:nvPr>
+            <p:ph type="sldImg" idx="2"/>
+          </p:nvPr>
+        </p:nvSpPr>
+        <p:spPr/>
+      </p:sp>
+      <p:sp>
+        <p:nvSpPr>
+          <p:cNvPr id="3" name="Notes Placeholder 2"/>
+          <p:cNvSpPr>
+            <a:spLocks noGrp="1"/>
+          </p:cNvSpPr>
+          <p:nvPr>
+            <p:ph type="body" idx="3" sz="quarter"/>
+          </p:nvPr>
+        </p:nvSpPr>
+        <p:spPr/>
+        <p:txBody>
+          <a:bodyPr/>
+          <a:lstStyle/>
+          <a:p>
+            <a:r>
+              <a:t>Zoom out. If labor stops being the constraint, then judgment becomes the differentiator — and judgment is what statistical training produces. I think the near future is each of us orchestrating a handful of agents across the taxonomy, with better audit trails than we have today because everything is logged and reproducible. The role doesn't shrink; it moves up the stack to the parts that were always the science.</a:t>
             </a:r>
           </a:p>
         </p:txBody>
@@ -1220,6 +1292,76 @@
           <a:p>
             <a:r>
               <a:t>Why is this a 2026 conversation and not a 2020 one? Three things matured at once: coding agents that can actually run and debug your pipeline, domain models trained for science, and GPUs cheap enough to sit under your desk. The consequence is that the rate-limiting step is no longer writing code or finding compute — it is posing a well-formed scientific question and validating the answer, which is exactly the statistician's strength.</a:t>
+            </a:r>
+          </a:p>
+        </p:txBody>
+      </p:sp>
+      <p:sp>
+        <p:nvSpPr>
+          <p:cNvPr id="4" name="Slide Number Placeholder 3"/>
+          <p:cNvSpPr>
+            <a:spLocks noGrp="1"/>
+          </p:cNvSpPr>
+          <p:nvPr>
+            <p:ph type="sldNum" idx="5" sz="quarter"/>
+          </p:nvPr>
+        </p:nvSpPr>
+        <p:spPr/>
+      </p:sp>
+    </p:spTree>
+  </p:cSld>
+  <p:clrMapOvr>
+    <a:masterClrMapping/>
+  </p:clrMapOvr>
+</p:notes>
+</file>
+
+<file path=ppt/notesSlides/notesSlide20.xml><?xml version="1.0" encoding="utf-8"?>
+<p:notes xmlns:a="http://schemas.openxmlformats.org/drawingml/2006/main" xmlns:p="http://schemas.openxmlformats.org/presentationml/2006/main" xmlns:r="http://schemas.openxmlformats.org/officeDocument/2006/relationships">
+  <p:cSld>
+    <p:spTree>
+      <p:nvGrpSpPr>
+        <p:cNvPr id="1" name=""/>
+        <p:cNvGrpSpPr/>
+        <p:nvPr/>
+      </p:nvGrpSpPr>
+      <p:grpSpPr>
+        <a:xfrm>
+          <a:off x="0" y="0"/>
+          <a:ext cx="0" cy="0"/>
+          <a:chOff x="0" y="0"/>
+          <a:chExt cx="0" cy="0"/>
+        </a:xfrm>
+      </p:grpSpPr>
+      <p:sp>
+        <p:nvSpPr>
+          <p:cNvPr id="2" name="Slide Image Placeholder 1"/>
+          <p:cNvSpPr>
+            <a:spLocks noGrp="1"/>
+          </p:cNvSpPr>
+          <p:nvPr>
+            <p:ph type="sldImg" idx="2"/>
+          </p:nvPr>
+        </p:nvSpPr>
+        <p:spPr/>
+      </p:sp>
+      <p:sp>
+        <p:nvSpPr>
+          <p:cNvPr id="3" name="Notes Placeholder 2"/>
+          <p:cNvSpPr>
+            <a:spLocks noGrp="1"/>
+          </p:cNvSpPr>
+          <p:nvPr>
+            <p:ph type="body" idx="3" sz="quarter"/>
+          </p:nvPr>
+        </p:nvSpPr>
+        <p:spPr/>
+        <p:txBody>
+          <a:bodyPr/>
+          <a:lstStyle/>
+          <a:p>
+            <a:r>
+              <a:t>Thank you. Everything I showed lives in the companion repo, including this deck and a one-page handout with copy-paste prompts you can try tonight. The whole thing is reproducible: python run_all_tests.py runs the tests, and each experiment's run_before_after.py regenerates its committed results. The papers on this slide are the verifiable anchors I built on — arXiv IDs so you can check them yourself — and the datasets are the standard open sources in our field. I'm happy to take questions, and I'm especially interested in where you think the human-in-the-loop checks need to be stronger.</a:t>
             </a:r>
           </a:p>
         </p:txBody>
@@ -5051,16 +5193,64 @@
           </a:p>
         </p:txBody>
       </p:sp>
-      <p:sp>
-        <p:nvSpPr>
-          <p:cNvPr id="4" name="TextBox 3"/>
+      <p:pic>
+        <p:nvPicPr>
+          <p:cNvPr id="4" name="Picture 3" descr="interaction_network.png"/>
+          <p:cNvPicPr>
+            <a:picLocks noChangeAspect="1"/>
+          </p:cNvPicPr>
+          <p:nvPr/>
+        </p:nvPicPr>
+        <p:blipFill>
+          <a:blip r:embed="rId2"/>
+          <a:stretch>
+            <a:fillRect/>
+          </a:stretch>
+        </p:blipFill>
+        <p:spPr>
+          <a:xfrm>
+            <a:off x="7576125" y="1417320"/>
+            <a:ext cx="2769989" cy="2112264"/>
+          </a:xfrm>
+          <a:prstGeom prst="rect">
+            <a:avLst/>
+          </a:prstGeom>
+        </p:spPr>
+      </p:pic>
+      <p:pic>
+        <p:nvPicPr>
+          <p:cNvPr id="5" name="Picture 4" descr="before_after_bars.png"/>
+          <p:cNvPicPr>
+            <a:picLocks noChangeAspect="1"/>
+          </p:cNvPicPr>
+          <p:nvPr/>
+        </p:nvPicPr>
+        <p:blipFill>
+          <a:blip r:embed="rId3"/>
+          <a:stretch>
+            <a:fillRect/>
+          </a:stretch>
+        </p:blipFill>
+        <p:spPr>
+          <a:xfrm>
+            <a:off x="7357569" y="3694176"/>
+            <a:ext cx="3207102" cy="2112264"/>
+          </a:xfrm>
+          <a:prstGeom prst="rect">
+            <a:avLst/>
+          </a:prstGeom>
+        </p:spPr>
+      </p:pic>
+      <p:sp>
+        <p:nvSpPr>
+          <p:cNvPr id="6" name="TextBox 5"/>
           <p:cNvSpPr txBox="1"/>
           <p:nvPr/>
         </p:nvSpPr>
         <p:spPr>
           <a:xfrm>
             <a:off x="640080" y="1371600"/>
-            <a:ext cx="10908792" cy="3840480"/>
+            <a:ext cx="5440680" cy="3840480"/>
           </a:xfrm>
           <a:prstGeom prst="rect">
             <a:avLst/>
@@ -5082,7 +5272,7 @@
               </a:spcAft>
             </a:pPr>
             <a:r>
-              <a:rPr sz="1800" b="1" i="0">
+              <a:rPr sz="1600" b="1" i="0">
                 <a:solidFill>
                   <a:srgbClr val="188038"/>
                 </a:solidFill>
@@ -5091,7 +5281,7 @@
               <a:t>•  </a:t>
             </a:r>
             <a:r>
-              <a:rPr sz="1800" b="0" i="0">
+              <a:rPr sz="1600" b="0" i="0">
                 <a:solidFill>
                   <a:srgbClr val="333333"/>
                 </a:solidFill>
@@ -5110,7 +5300,7 @@
               </a:spcAft>
             </a:pPr>
             <a:r>
-              <a:rPr sz="1800" b="1" i="0">
+              <a:rPr sz="1600" b="1" i="0">
                 <a:solidFill>
                   <a:srgbClr val="188038"/>
                 </a:solidFill>
@@ -5119,7 +5309,7 @@
               <a:t>•  </a:t>
             </a:r>
             <a:r>
-              <a:rPr sz="1800" b="0" i="0">
+              <a:rPr sz="1600" b="0" i="0">
                 <a:solidFill>
                   <a:srgbClr val="333333"/>
                 </a:solidFill>
@@ -5138,7 +5328,7 @@
               </a:spcAft>
             </a:pPr>
             <a:r>
-              <a:rPr sz="1800" b="1" i="0">
+              <a:rPr sz="1600" b="1" i="0">
                 <a:solidFill>
                   <a:srgbClr val="188038"/>
                 </a:solidFill>
@@ -5147,7 +5337,7 @@
               <a:t>•  </a:t>
             </a:r>
             <a:r>
-              <a:rPr sz="1800" b="0" i="0">
+              <a:rPr sz="1600" b="0" i="0">
                 <a:solidFill>
                   <a:srgbClr val="333333"/>
                 </a:solidFill>
@@ -5166,7 +5356,7 @@
               </a:spcAft>
             </a:pPr>
             <a:r>
-              <a:rPr sz="1800" b="1" i="0">
+              <a:rPr sz="1600" b="1" i="0">
                 <a:solidFill>
                   <a:srgbClr val="188038"/>
                 </a:solidFill>
@@ -5175,7 +5365,7 @@
               <a:t>•  </a:t>
             </a:r>
             <a:r>
-              <a:rPr sz="1800" b="0" i="0">
+              <a:rPr sz="1600" b="0" i="0">
                 <a:solidFill>
                   <a:srgbClr val="333333"/>
                 </a:solidFill>
@@ -5194,7 +5384,7 @@
               </a:spcAft>
             </a:pPr>
             <a:r>
-              <a:rPr sz="1800" b="1" i="0">
+              <a:rPr sz="1600" b="1" i="0">
                 <a:solidFill>
                   <a:srgbClr val="188038"/>
                 </a:solidFill>
@@ -5203,7 +5393,7 @@
               <a:t>•  </a:t>
             </a:r>
             <a:r>
-              <a:rPr sz="1800" b="0" i="0">
+              <a:rPr sz="1600" b="0" i="0">
                 <a:solidFill>
                   <a:srgbClr val="333333"/>
                 </a:solidFill>
@@ -5216,14 +5406,14 @@
       </p:sp>
       <p:sp>
         <p:nvSpPr>
-          <p:cNvPr id="5" name="TextBox 4"/>
+          <p:cNvPr id="7" name="TextBox 6"/>
           <p:cNvSpPr txBox="1"/>
           <p:nvPr/>
         </p:nvSpPr>
         <p:spPr>
           <a:xfrm>
-            <a:off x="640080" y="5349240"/>
-            <a:ext cx="10908792" cy="640080"/>
+            <a:off x="640080" y="5440680"/>
+            <a:ext cx="5440680" cy="548640"/>
           </a:xfrm>
           <a:prstGeom prst="rect">
             <a:avLst/>
@@ -5237,20 +5427,20 @@
           <a:lstStyle/>
           <a:p>
             <a:r>
-              <a:rPr sz="1100" b="0" i="1">
+              <a:rPr sz="1000" b="0" i="1">
                 <a:solidFill>
                   <a:srgbClr val="9AA0A6"/>
                 </a:solidFill>
                 <a:latin typeface="Calibri"/>
               </a:rPr>
-              <a:t>[Visual placeholder] Side-by-side: a sparse regex-derived graph vs a richer LLM-derived interaction network; precision/recall bars beneath.</a:t>
-            </a:r>
-          </a:p>
-        </p:txBody>
-      </p:sp>
-      <p:sp>
-        <p:nvSpPr>
-          <p:cNvPr id="6" name="TextBox 5"/>
+              <a:t>[Figure: committed result] Side-by-side: a sparse regex-derived graph vs a richer LLM-derived interaction network; precision/recall bars beneath.</a:t>
+            </a:r>
+          </a:p>
+        </p:txBody>
+      </p:sp>
+      <p:sp>
+        <p:nvSpPr>
+          <p:cNvPr id="8" name="TextBox 7"/>
           <p:cNvSpPr txBox="1"/>
           <p:nvPr/>
         </p:nvSpPr>
@@ -5386,16 +5576,64 @@
           </a:p>
         </p:txBody>
       </p:sp>
-      <p:sp>
-        <p:nvSpPr>
-          <p:cNvPr id="4" name="TextBox 3"/>
+      <p:pic>
+        <p:nvPicPr>
+          <p:cNvPr id="4" name="Picture 3" descr="before_after_hard_bars.png"/>
+          <p:cNvPicPr>
+            <a:picLocks noChangeAspect="1"/>
+          </p:cNvPicPr>
+          <p:nvPr/>
+        </p:nvPicPr>
+        <p:blipFill>
+          <a:blip r:embed="rId2"/>
+          <a:stretch>
+            <a:fillRect/>
+          </a:stretch>
+        </p:blipFill>
+        <p:spPr>
+          <a:xfrm>
+            <a:off x="7440511" y="1417320"/>
+            <a:ext cx="3041218" cy="2112264"/>
+          </a:xfrm>
+          <a:prstGeom prst="rect">
+            <a:avLst/>
+          </a:prstGeom>
+        </p:spPr>
+      </p:pic>
+      <p:pic>
+        <p:nvPicPr>
+          <p:cNvPr id="5" name="Picture 4" descr="change_map.png"/>
+          <p:cNvPicPr>
+            <a:picLocks noChangeAspect="1"/>
+          </p:cNvPicPr>
+          <p:nvPr/>
+        </p:nvPicPr>
+        <p:blipFill>
+          <a:blip r:embed="rId3"/>
+          <a:stretch>
+            <a:fillRect/>
+          </a:stretch>
+        </p:blipFill>
+        <p:spPr>
+          <a:xfrm>
+            <a:off x="7782799" y="3694176"/>
+            <a:ext cx="2356641" cy="2112264"/>
+          </a:xfrm>
+          <a:prstGeom prst="rect">
+            <a:avLst/>
+          </a:prstGeom>
+        </p:spPr>
+      </p:pic>
+      <p:sp>
+        <p:nvSpPr>
+          <p:cNvPr id="6" name="TextBox 5"/>
           <p:cNvSpPr txBox="1"/>
           <p:nvPr/>
         </p:nvSpPr>
         <p:spPr>
           <a:xfrm>
             <a:off x="640080" y="1371600"/>
-            <a:ext cx="10908792" cy="3840480"/>
+            <a:ext cx="5440680" cy="3840480"/>
           </a:xfrm>
           <a:prstGeom prst="rect">
             <a:avLst/>
@@ -5417,7 +5655,7 @@
               </a:spcAft>
             </a:pPr>
             <a:r>
-              <a:rPr sz="1800" b="1" i="0">
+              <a:rPr sz="1600" b="1" i="0">
                 <a:solidFill>
                   <a:srgbClr val="188038"/>
                 </a:solidFill>
@@ -5426,7 +5664,7 @@
               <a:t>•  </a:t>
             </a:r>
             <a:r>
-              <a:rPr sz="1800" b="0" i="0">
+              <a:rPr sz="1600" b="0" i="0">
                 <a:solidFill>
                   <a:srgbClr val="333333"/>
                 </a:solidFill>
@@ -5445,7 +5683,7 @@
               </a:spcAft>
             </a:pPr>
             <a:r>
-              <a:rPr sz="1800" b="1" i="0">
+              <a:rPr sz="1600" b="1" i="0">
                 <a:solidFill>
                   <a:srgbClr val="188038"/>
                 </a:solidFill>
@@ -5454,7 +5692,7 @@
               <a:t>•  </a:t>
             </a:r>
             <a:r>
-              <a:rPr sz="1800" b="0" i="0">
+              <a:rPr sz="1600" b="0" i="0">
                 <a:solidFill>
                   <a:srgbClr val="333333"/>
                 </a:solidFill>
@@ -5473,7 +5711,7 @@
               </a:spcAft>
             </a:pPr>
             <a:r>
-              <a:rPr sz="1800" b="1" i="0">
+              <a:rPr sz="1600" b="1" i="0">
                 <a:solidFill>
                   <a:srgbClr val="188038"/>
                 </a:solidFill>
@@ -5482,7 +5720,7 @@
               <a:t>•  </a:t>
             </a:r>
             <a:r>
-              <a:rPr sz="1800" b="0" i="0">
+              <a:rPr sz="1600" b="0" i="0">
                 <a:solidFill>
                   <a:srgbClr val="333333"/>
                 </a:solidFill>
@@ -5501,7 +5739,7 @@
               </a:spcAft>
             </a:pPr>
             <a:r>
-              <a:rPr sz="1800" b="1" i="0">
+              <a:rPr sz="1600" b="1" i="0">
                 <a:solidFill>
                   <a:srgbClr val="188038"/>
                 </a:solidFill>
@@ -5510,7 +5748,7 @@
               <a:t>•  </a:t>
             </a:r>
             <a:r>
-              <a:rPr sz="1800" b="0" i="0">
+              <a:rPr sz="1600" b="0" i="0">
                 <a:solidFill>
                   <a:srgbClr val="333333"/>
                 </a:solidFill>
@@ -5529,7 +5767,7 @@
               </a:spcAft>
             </a:pPr>
             <a:r>
-              <a:rPr sz="1800" b="1" i="0">
+              <a:rPr sz="1600" b="1" i="0">
                 <a:solidFill>
                   <a:srgbClr val="188038"/>
                 </a:solidFill>
@@ -5538,7 +5776,7 @@
               <a:t>•  </a:t>
             </a:r>
             <a:r>
-              <a:rPr sz="1800" b="0" i="0">
+              <a:rPr sz="1600" b="0" i="0">
                 <a:solidFill>
                   <a:srgbClr val="333333"/>
                 </a:solidFill>
@@ -5551,14 +5789,14 @@
       </p:sp>
       <p:sp>
         <p:nvSpPr>
-          <p:cNvPr id="5" name="TextBox 4"/>
+          <p:cNvPr id="7" name="TextBox 6"/>
           <p:cNvSpPr txBox="1"/>
           <p:nvPr/>
         </p:nvSpPr>
         <p:spPr>
           <a:xfrm>
-            <a:off x="640080" y="5349240"/>
-            <a:ext cx="10908792" cy="640080"/>
+            <a:off x="640080" y="5440680"/>
+            <a:ext cx="5440680" cy="548640"/>
           </a:xfrm>
           <a:prstGeom prst="rect">
             <a:avLst/>
@@ -5572,20 +5810,20 @@
           <a:lstStyle/>
           <a:p>
             <a:r>
-              <a:rPr sz="1100" b="0" i="1">
+              <a:rPr sz="1000" b="0" i="1">
                 <a:solidFill>
                   <a:srgbClr val="9AA0A6"/>
                 </a:solidFill>
                 <a:latin typeface="Calibri"/>
               </a:rPr>
-              <a:t>[Visual placeholder] A classified land-cover map and a change-detection map side by side; accuracy/F1 comparison bar.</a:t>
-            </a:r>
-          </a:p>
-        </p:txBody>
-      </p:sp>
-      <p:sp>
-        <p:nvSpPr>
-          <p:cNvPr id="6" name="TextBox 5"/>
+              <a:t>[Figure: committed result] A classified land-cover map and a change-detection map side by side; accuracy/F1 comparison bar.</a:t>
+            </a:r>
+          </a:p>
+        </p:txBody>
+      </p:sp>
+      <p:sp>
+        <p:nvSpPr>
+          <p:cNvPr id="8" name="TextBox 7"/>
           <p:cNvSpPr txBox="1"/>
           <p:nvPr/>
         </p:nvSpPr>
@@ -5631,7 +5869,7 @@
     <p:bg>
       <p:bgPr>
         <a:solidFill>
-          <a:srgbClr val="1A3A5C"/>
+          <a:srgbClr val="FFFFFF"/>
         </a:solidFill>
         <a:effectLst/>
       </p:bgPr>
@@ -5645,14 +5883,58 @@
       <p:grpSpPr/>
       <p:sp>
         <p:nvSpPr>
-          <p:cNvPr id="2" name="TextBox 1"/>
+          <p:cNvPr id="2" name="Rectangle 1"/>
+          <p:cNvSpPr/>
+          <p:nvPr/>
+        </p:nvSpPr>
+        <p:spPr>
+          <a:xfrm>
+            <a:off x="0" y="0"/>
+            <a:ext cx="12191695" cy="146304"/>
+          </a:xfrm>
+          <a:prstGeom prst="rect">
+            <a:avLst/>
+          </a:prstGeom>
+          <a:solidFill>
+            <a:srgbClr val="1A3A5C"/>
+          </a:solidFill>
+          <a:ln>
+            <a:noFill/>
+          </a:ln>
+          <a:effectLst/>
+        </p:spPr>
+        <p:style>
+          <a:lnRef idx="1">
+            <a:schemeClr val="accent1"/>
+          </a:lnRef>
+          <a:fillRef idx="3">
+            <a:schemeClr val="accent1"/>
+          </a:fillRef>
+          <a:effectRef idx="2">
+            <a:schemeClr val="accent1"/>
+          </a:effectRef>
+          <a:fontRef idx="minor">
+            <a:schemeClr val="lt1"/>
+          </a:fontRef>
+        </p:style>
+        <p:txBody>
+          <a:bodyPr rtlCol="0" anchor="ctr"/>
+          <a:lstStyle/>
+          <a:p>
+            <a:pPr algn="ctr"/>
+          </a:p>
+        </p:txBody>
+      </p:sp>
+      <p:sp>
+        <p:nvSpPr>
+          <p:cNvPr id="3" name="TextBox 2"/>
           <p:cNvSpPr txBox="1"/>
           <p:nvPr/>
         </p:nvSpPr>
         <p:spPr>
           <a:xfrm>
-            <a:off x="822960" y="2468880"/>
-            <a:ext cx="10515600" cy="1828800"/>
+            <a:off x="640080" y="292608"/>
+            <a:ext cx="10908792" cy="914400"/>
           </a:xfrm>
           <a:prstGeom prst="rect">
             <a:avLst/>
@@ -5666,29 +5948,292 @@
           <a:lstStyle/>
           <a:p>
             <a:r>
-              <a:rPr sz="1800" b="1" i="0">
-                <a:solidFill>
-                  <a:srgbClr val="BFD8C2"/>
-                </a:solidFill>
-                <a:latin typeface="Calibri"/>
-              </a:rPr>
-              <a:t>THE FLAGSHIP</a:t>
-            </a:r>
-          </a:p>
+              <a:rPr sz="2800" b="1" i="0">
+                <a:solidFill>
+                  <a:srgbClr val="1A3A5C"/>
+                </a:solidFill>
+                <a:latin typeface="Calibri"/>
+              </a:rPr>
+              <a:t>Bonus demo: Hydrology rainfall-runoff — Exp08</a:t>
+            </a:r>
+          </a:p>
+        </p:txBody>
+      </p:sp>
+      <p:pic>
+        <p:nvPicPr>
+          <p:cNvPr id="4" name="Picture 3" descr="hydrograph.png"/>
+          <p:cNvPicPr>
+            <a:picLocks noChangeAspect="1"/>
+          </p:cNvPicPr>
+          <p:nvPr/>
+        </p:nvPicPr>
+        <p:blipFill>
+          <a:blip r:embed="rId2"/>
+          <a:stretch>
+            <a:fillRect/>
+          </a:stretch>
+        </p:blipFill>
+        <p:spPr>
+          <a:xfrm>
+            <a:off x="6654120" y="1417320"/>
+            <a:ext cx="4613999" cy="2112264"/>
+          </a:xfrm>
+          <a:prstGeom prst="rect">
+            <a:avLst/>
+          </a:prstGeom>
+        </p:spPr>
+      </p:pic>
+      <p:pic>
+        <p:nvPicPr>
+          <p:cNvPr id="5" name="Picture 4" descr="before_after_bars.png"/>
+          <p:cNvPicPr>
+            <a:picLocks noChangeAspect="1"/>
+          </p:cNvPicPr>
+          <p:nvPr/>
+        </p:nvPicPr>
+        <p:blipFill>
+          <a:blip r:embed="rId3"/>
+          <a:stretch>
+            <a:fillRect/>
+          </a:stretch>
+        </p:blipFill>
+        <p:spPr>
+          <a:xfrm>
+            <a:off x="7440511" y="3694176"/>
+            <a:ext cx="3041218" cy="2112264"/>
+          </a:xfrm>
+          <a:prstGeom prst="rect">
+            <a:avLst/>
+          </a:prstGeom>
+        </p:spPr>
+      </p:pic>
+      <p:sp>
+        <p:nvSpPr>
+          <p:cNvPr id="6" name="TextBox 5"/>
+          <p:cNvSpPr txBox="1"/>
+          <p:nvPr/>
+        </p:nvSpPr>
+        <p:spPr>
+          <a:xfrm>
+            <a:off x="640080" y="1371600"/>
+            <a:ext cx="5440680" cy="3840480"/>
+          </a:xfrm>
+          <a:prstGeom prst="rect">
+            <a:avLst/>
+          </a:prstGeom>
+          <a:noFill/>
+        </p:spPr>
+        <p:txBody>
+          <a:bodyPr wrap="square">
+            <a:spAutoFit/>
+          </a:bodyPr>
+          <a:lstStyle/>
           <a:p>
             <a:pPr>
-              <a:spcBef>
-                <a:spcPts val="800"/>
-              </a:spcBef>
+              <a:lnSpc>
+                <a:spcPct val="110000"/>
+              </a:lnSpc>
+              <a:spcAft>
+                <a:spcPts val="1200"/>
+              </a:spcAft>
             </a:pPr>
             <a:r>
-              <a:rPr sz="3400" b="1" i="0">
-                <a:solidFill>
-                  <a:srgbClr val="FFFFFF"/>
-                </a:solidFill>
-                <a:latin typeface="Calibri"/>
-              </a:rPr>
-              <a:t>An autonomous research loop — Exp05</a:t>
+              <a:rPr sz="1600" b="1" i="0">
+                <a:solidFill>
+                  <a:srgbClr val="188038"/>
+                </a:solidFill>
+                <a:latin typeface="Calibri"/>
+              </a:rPr>
+              <a:t>•  </a:t>
+            </a:r>
+            <a:r>
+              <a:rPr sz="1600" b="0" i="0">
+                <a:solidFill>
+                  <a:srgbClr val="333333"/>
+                </a:solidFill>
+                <a:latin typeface="Calibri"/>
+              </a:rPr>
+              <a:t>Task: predict daily streamflow from rainfall on a synthetic catchment; metric NSE / KGE</a:t>
+            </a:r>
+          </a:p>
+          <a:p>
+            <a:pPr>
+              <a:lnSpc>
+                <a:spcPct val="110000"/>
+              </a:lnSpc>
+              <a:spcAft>
+                <a:spcPts val="1200"/>
+              </a:spcAft>
+            </a:pPr>
+            <a:r>
+              <a:rPr sz="1600" b="1" i="0">
+                <a:solidFill>
+                  <a:srgbClr val="188038"/>
+                </a:solidFill>
+                <a:latin typeface="Calibri"/>
+              </a:rPr>
+              <a:t>•  </a:t>
+            </a:r>
+            <a:r>
+              <a:rPr sz="1600" b="0" i="0">
+                <a:solidFill>
+                  <a:srgbClr val="333333"/>
+                </a:solidFill>
+                <a:latin typeface="Calibri"/>
+              </a:rPr>
+              <a:t>BEFORE: linear / conceptual bucket model — NSE 0.14 (can't carry catchment state)</a:t>
+            </a:r>
+          </a:p>
+          <a:p>
+            <a:pPr>
+              <a:lnSpc>
+                <a:spcPct val="110000"/>
+              </a:lnSpc>
+              <a:spcAft>
+                <a:spcPts val="1200"/>
+              </a:spcAft>
+            </a:pPr>
+            <a:r>
+              <a:rPr sz="1600" b="1" i="0">
+                <a:solidFill>
+                  <a:srgbClr val="188038"/>
+                </a:solidFill>
+                <a:latin typeface="Calibri"/>
+              </a:rPr>
+              <a:t>•  </a:t>
+            </a:r>
+            <a:r>
+              <a:rPr sz="1600" b="0" i="0">
+                <a:solidFill>
+                  <a:srgbClr val="333333"/>
+                </a:solidFill>
+                <a:latin typeface="Calibri"/>
+              </a:rPr>
+              <a:t>AFTER: LSTM rainfall-runoff model — NSE 0.70 (+0.56 NSE / +0.51 KGE)</a:t>
+            </a:r>
+          </a:p>
+          <a:p>
+            <a:pPr>
+              <a:lnSpc>
+                <a:spcPct val="110000"/>
+              </a:lnSpc>
+              <a:spcAft>
+                <a:spcPts val="1200"/>
+              </a:spcAft>
+            </a:pPr>
+            <a:r>
+              <a:rPr sz="1600" b="1" i="0">
+                <a:solidFill>
+                  <a:srgbClr val="188038"/>
+                </a:solidFill>
+                <a:latin typeface="Calibri"/>
+              </a:rPr>
+              <a:t>•  </a:t>
+            </a:r>
+            <a:r>
+              <a:rPr sz="1600" b="0" i="0">
+                <a:solidFill>
+                  <a:srgbClr val="333333"/>
+                </a:solidFill>
+                <a:latin typeface="Calibri"/>
+              </a:rPr>
+              <a:t>Why it wins: the LSTM carries soil-moisture / snow / routing state the linear model drops</a:t>
+            </a:r>
+          </a:p>
+          <a:p>
+            <a:pPr>
+              <a:lnSpc>
+                <a:spcPct val="110000"/>
+              </a:lnSpc>
+              <a:spcAft>
+                <a:spcPts val="1200"/>
+              </a:spcAft>
+            </a:pPr>
+            <a:r>
+              <a:rPr sz="1600" b="1" i="0">
+                <a:solidFill>
+                  <a:srgbClr val="188038"/>
+                </a:solidFill>
+                <a:latin typeface="Calibri"/>
+              </a:rPr>
+              <a:t>•  </a:t>
+            </a:r>
+            <a:r>
+              <a:rPr sz="1600" b="0" i="0">
+                <a:solidFill>
+                  <a:srgbClr val="333333"/>
+                </a:solidFill>
+                <a:latin typeface="Calibri"/>
+              </a:rPr>
+              <a:t>Command: python experiments/08_hydrology_streamflow/run_before_after.py</a:t>
+            </a:r>
+          </a:p>
+        </p:txBody>
+      </p:sp>
+      <p:sp>
+        <p:nvSpPr>
+          <p:cNvPr id="7" name="TextBox 6"/>
+          <p:cNvSpPr txBox="1"/>
+          <p:nvPr/>
+        </p:nvSpPr>
+        <p:spPr>
+          <a:xfrm>
+            <a:off x="640080" y="5440680"/>
+            <a:ext cx="5440680" cy="548640"/>
+          </a:xfrm>
+          <a:prstGeom prst="rect">
+            <a:avLst/>
+          </a:prstGeom>
+          <a:noFill/>
+        </p:spPr>
+        <p:txBody>
+          <a:bodyPr wrap="square">
+            <a:spAutoFit/>
+          </a:bodyPr>
+          <a:lstStyle/>
+          <a:p>
+            <a:r>
+              <a:rPr sz="1000" b="0" i="1">
+                <a:solidFill>
+                  <a:srgbClr val="9AA0A6"/>
+                </a:solidFill>
+                <a:latin typeface="Calibri"/>
+              </a:rPr>
+              <a:t>[Figure: committed result] Observed-vs-predicted hydrograph (BEFORE linear vs AFTER LSTM) plus a BEFORE/AFTER NSE bar.</a:t>
+            </a:r>
+          </a:p>
+        </p:txBody>
+      </p:sp>
+      <p:sp>
+        <p:nvSpPr>
+          <p:cNvPr id="8" name="TextBox 7"/>
+          <p:cNvSpPr txBox="1"/>
+          <p:nvPr/>
+        </p:nvSpPr>
+        <p:spPr>
+          <a:xfrm>
+            <a:off x="640080" y="5989320"/>
+            <a:ext cx="10908792" cy="640080"/>
+          </a:xfrm>
+          <a:prstGeom prst="rect">
+            <a:avLst/>
+          </a:prstGeom>
+          <a:noFill/>
+        </p:spPr>
+        <p:txBody>
+          <a:bodyPr wrap="square" anchor="ctr">
+            <a:spAutoFit/>
+          </a:bodyPr>
+          <a:lstStyle/>
+          <a:p>
+            <a:r>
+              <a:rPr sz="1600" b="1" i="0">
+                <a:solidFill>
+                  <a:srgbClr val="188038"/>
+                </a:solidFill>
+                <a:latin typeface="Calibri"/>
+              </a:rPr>
+              <a:t>TAKEAWAY: A clean AFTER win: the classic LSTM-hydrology result, reproduced in one command.</a:t>
             </a:r>
           </a:p>
         </p:txBody>
@@ -5792,21 +6337,45 @@
                 </a:solidFill>
                 <a:latin typeface="Calibri"/>
               </a:rPr>
-              <a:t>The flagship: an autonomous research loop — Exp05</a:t>
-            </a:r>
-          </a:p>
-        </p:txBody>
-      </p:sp>
-      <p:sp>
-        <p:nvSpPr>
-          <p:cNvPr id="4" name="TextBox 3"/>
+              <a:t>Bonus demo: Calibrated uncertainty — Exp12</a:t>
+            </a:r>
+          </a:p>
+        </p:txBody>
+      </p:sp>
+      <p:pic>
+        <p:nvPicPr>
+          <p:cNvPr id="4" name="Picture 3" descr="coverage_plot.png"/>
+          <p:cNvPicPr>
+            <a:picLocks noChangeAspect="1"/>
+          </p:cNvPicPr>
+          <p:nvPr/>
+        </p:nvPicPr>
+        <p:blipFill>
+          <a:blip r:embed="rId2"/>
+          <a:stretch>
+            <a:fillRect/>
+          </a:stretch>
+        </p:blipFill>
+        <p:spPr>
+          <a:xfrm>
+            <a:off x="6837352" y="1417320"/>
+            <a:ext cx="4247535" cy="4389120"/>
+          </a:xfrm>
+          <a:prstGeom prst="rect">
+            <a:avLst/>
+          </a:prstGeom>
+        </p:spPr>
+      </p:pic>
+      <p:sp>
+        <p:nvSpPr>
+          <p:cNvPr id="5" name="TextBox 4"/>
           <p:cNvSpPr txBox="1"/>
           <p:nvPr/>
         </p:nvSpPr>
         <p:spPr>
           <a:xfrm>
             <a:off x="640080" y="1371600"/>
-            <a:ext cx="10908792" cy="3840480"/>
+            <a:ext cx="5440680" cy="3840480"/>
           </a:xfrm>
           <a:prstGeom prst="rect">
             <a:avLst/>
@@ -5828,7 +6397,7 @@
               </a:spcAft>
             </a:pPr>
             <a:r>
-              <a:rPr sz="1800" b="1" i="0">
+              <a:rPr sz="1600" b="1" i="0">
                 <a:solidFill>
                   <a:srgbClr val="188038"/>
                 </a:solidFill>
@@ -5837,13 +6406,13 @@
               <a:t>•  </a:t>
             </a:r>
             <a:r>
-              <a:rPr sz="1800" b="0" i="0">
+              <a:rPr sz="1600" b="0" i="0">
                 <a:solidFill>
                   <a:srgbClr val="333333"/>
                 </a:solidFill>
                 <a:latin typeface="Calibri"/>
               </a:rPr>
-              <a:t>The agent is the researcher: Diagnose → Cite → Hypothesize → Predict → Execute → Analyze → Checkpoint</a:t>
+              <a:t>Task: build prediction intervals that actually cover at the nominal rate</a:t>
             </a:r>
           </a:p>
           <a:p>
@@ -5856,7 +6425,7 @@
               </a:spcAft>
             </a:pPr>
             <a:r>
-              <a:rPr sz="1800" b="1" i="0">
+              <a:rPr sz="1600" b="1" i="0">
                 <a:solidFill>
                   <a:srgbClr val="188038"/>
                 </a:solidFill>
@@ -5865,13 +6434,13 @@
               <a:t>•  </a:t>
             </a:r>
             <a:r>
-              <a:rPr sz="1800" b="0" i="0">
+              <a:rPr sz="1600" b="0" i="0">
                 <a:solidFill>
                   <a:srgbClr val="333333"/>
                 </a:solidFill>
                 <a:latin typeface="Calibri"/>
               </a:rPr>
-              <a:t>Hard gates before any run: citation-rigor + reasoning-completeness (no ungrounded experiments)</a:t>
+              <a:t>BEFORE: normal-theory PIs — 80% nominal but 86.9% empirical (miscalibrated under heavy tails)</a:t>
             </a:r>
           </a:p>
           <a:p>
@@ -5884,7 +6453,7 @@
               </a:spcAft>
             </a:pPr>
             <a:r>
-              <a:rPr sz="1800" b="1" i="0">
+              <a:rPr sz="1600" b="1" i="0">
                 <a:solidFill>
                   <a:srgbClr val="188038"/>
                 </a:solidFill>
@@ -5893,13 +6462,13 @@
               <a:t>•  </a:t>
             </a:r>
             <a:r>
-              <a:rPr sz="1800" b="0" i="0">
+              <a:rPr sz="1600" b="0" i="0">
                 <a:solidFill>
                   <a:srgbClr val="333333"/>
                 </a:solidFill>
                 <a:latin typeface="Calibri"/>
               </a:rPr>
-              <a:t>Gated 6-experiment loop ran in ~38 s; champion +8.0% skill (RMSE 1.95→1.79 °C), monotone composite</a:t>
+              <a:t>AFTER: split / normalized conformal PIs — distribution-free finite-sample coverage</a:t>
             </a:r>
           </a:p>
           <a:p>
@@ -5912,7 +6481,7 @@
               </a:spcAft>
             </a:pPr>
             <a:r>
-              <a:rPr sz="1800" b="1" i="0">
+              <a:rPr sz="1600" b="1" i="0">
                 <a:solidFill>
                   <a:srgbClr val="188038"/>
                 </a:solidFill>
@@ -5921,13 +6490,13 @@
               <a:t>•  </a:t>
             </a:r>
             <a:r>
-              <a:rPr sz="1800" b="0" i="0">
+              <a:rPr sz="1600" b="0" i="0">
                 <a:solidFill>
                   <a:srgbClr val="333333"/>
                 </a:solidFill>
                 <a:latin typeface="Calibri"/>
               </a:rPr>
-              <a:t>Adapted from the user's own dlmastery/autoresearch (generalized_ml_autoresearch)</a:t>
+              <a:t>Result: mean coverage gap 0.033 → 0.004 (~7× tighter) AND narrower bands (6.37 → 5.22 °C at 80%)</a:t>
             </a:r>
           </a:p>
           <a:p>
@@ -5940,7 +6509,7 @@
               </a:spcAft>
             </a:pPr>
             <a:r>
-              <a:rPr sz="1800" b="1" i="0">
+              <a:rPr sz="1600" b="1" i="0">
                 <a:solidFill>
                   <a:srgbClr val="188038"/>
                 </a:solidFill>
@@ -5949,27 +6518,27 @@
               <a:t>•  </a:t>
             </a:r>
             <a:r>
-              <a:rPr sz="1800" b="0" i="0">
+              <a:rPr sz="1600" b="0" i="0">
                 <a:solidFill>
                   <a:srgbClr val="333333"/>
                 </a:solidFill>
                 <a:latin typeface="Calibri"/>
               </a:rPr>
-              <a:t>Pluggable backbones / splits / composite metric; champion archive + research journal; runs on one 4090</a:t>
-            </a:r>
-          </a:p>
-        </p:txBody>
-      </p:sp>
-      <p:sp>
-        <p:nvSpPr>
-          <p:cNvPr id="5" name="TextBox 4"/>
+              <a:t>Command: python experiments/12_conformal_uncertainty/run_before_after.py</a:t>
+            </a:r>
+          </a:p>
+        </p:txBody>
+      </p:sp>
+      <p:sp>
+        <p:nvSpPr>
+          <p:cNvPr id="6" name="TextBox 5"/>
           <p:cNvSpPr txBox="1"/>
           <p:nvPr/>
         </p:nvSpPr>
         <p:spPr>
           <a:xfrm>
-            <a:off x="640080" y="5349240"/>
-            <a:ext cx="10908792" cy="640080"/>
+            <a:off x="640080" y="5440680"/>
+            <a:ext cx="5440680" cy="548640"/>
           </a:xfrm>
           <a:prstGeom prst="rect">
             <a:avLst/>
@@ -5983,20 +6552,20 @@
           <a:lstStyle/>
           <a:p>
             <a:r>
-              <a:rPr sz="1100" b="0" i="1">
+              <a:rPr sz="1000" b="0" i="1">
                 <a:solidFill>
                   <a:srgbClr val="9AA0A6"/>
                 </a:solidFill>
                 <a:latin typeface="Calibri"/>
               </a:rPr>
-              <a:t>[Visual placeholder] The 7-step loop as a circle with the two hard gates drawn as locks before "Execute"; a thumbnail of the champion-archive folder + research-journal entry. Reference docs/autoresearch_protocol.md.</a:t>
-            </a:r>
-          </a:p>
-        </p:txBody>
-      </p:sp>
-      <p:sp>
-        <p:nvSpPr>
-          <p:cNvPr id="6" name="TextBox 5"/>
+              <a:t>[Figure: committed result] Coverage plot: nominal vs empirical coverage for normal-theory vs conformal PIs across target levels.</a:t>
+            </a:r>
+          </a:p>
+        </p:txBody>
+      </p:sp>
+      <p:sp>
+        <p:nvSpPr>
+          <p:cNvPr id="7" name="TextBox 6"/>
           <p:cNvSpPr txBox="1"/>
           <p:nvPr/>
         </p:nvSpPr>
@@ -6023,7 +6592,7 @@
                 </a:solidFill>
                 <a:latin typeface="Calibri"/>
               </a:rPr>
-              <a:t>TAKEAWAY: The loop makes the agent a researcher — gated so it can't fish for significance.</a:t>
+              <a:t>TAKEAWAY: Conformal prediction makes uncertainty honest: calibrated coverage and sharper bands.</a:t>
             </a:r>
           </a:p>
         </p:txBody>
@@ -6042,7 +6611,7 @@
     <p:bg>
       <p:bgPr>
         <a:solidFill>
-          <a:srgbClr val="FFFFFF"/>
+          <a:srgbClr val="1A3A5C"/>
         </a:solidFill>
         <a:effectLst/>
       </p:bgPr>
@@ -6056,58 +6625,14 @@
       <p:grpSpPr/>
       <p:sp>
         <p:nvSpPr>
-          <p:cNvPr id="2" name="Rectangle 1"/>
-          <p:cNvSpPr/>
-          <p:nvPr/>
-        </p:nvSpPr>
-        <p:spPr>
-          <a:xfrm>
-            <a:off x="0" y="0"/>
-            <a:ext cx="12191695" cy="146304"/>
-          </a:xfrm>
-          <a:prstGeom prst="rect">
-            <a:avLst/>
-          </a:prstGeom>
-          <a:solidFill>
-            <a:srgbClr val="1A3A5C"/>
-          </a:solidFill>
-          <a:ln>
-            <a:noFill/>
-          </a:ln>
-          <a:effectLst/>
-        </p:spPr>
-        <p:style>
-          <a:lnRef idx="1">
-            <a:schemeClr val="accent1"/>
-          </a:lnRef>
-          <a:fillRef idx="3">
-            <a:schemeClr val="accent1"/>
-          </a:fillRef>
-          <a:effectRef idx="2">
-            <a:schemeClr val="accent1"/>
-          </a:effectRef>
-          <a:fontRef idx="minor">
-            <a:schemeClr val="lt1"/>
-          </a:fontRef>
-        </p:style>
-        <p:txBody>
-          <a:bodyPr rtlCol="0" anchor="ctr"/>
-          <a:lstStyle/>
-          <a:p>
-            <a:pPr algn="ctr"/>
-          </a:p>
-        </p:txBody>
-      </p:sp>
-      <p:sp>
-        <p:nvSpPr>
-          <p:cNvPr id="3" name="TextBox 2"/>
+          <p:cNvPr id="2" name="TextBox 1"/>
           <p:cNvSpPr txBox="1"/>
           <p:nvPr/>
         </p:nvSpPr>
         <p:spPr>
           <a:xfrm>
-            <a:off x="640080" y="292608"/>
-            <a:ext cx="10908792" cy="914400"/>
+            <a:off x="822960" y="2468880"/>
+            <a:ext cx="10515600" cy="1828800"/>
           </a:xfrm>
           <a:prstGeom prst="rect">
             <a:avLst/>
@@ -6121,244 +6646,29 @@
           <a:lstStyle/>
           <a:p>
             <a:r>
-              <a:rPr sz="2800" b="1" i="0">
-                <a:solidFill>
-                  <a:srgbClr val="1A3A5C"/>
-                </a:solidFill>
-                <a:latin typeface="Calibri"/>
-              </a:rPr>
-              <a:t>Autoresearch, honestly: what it does and doesn't do</a:t>
-            </a:r>
-          </a:p>
-        </p:txBody>
-      </p:sp>
-      <p:sp>
-        <p:nvSpPr>
-          <p:cNvPr id="4" name="TextBox 3"/>
-          <p:cNvSpPr txBox="1"/>
-          <p:nvPr/>
-        </p:nvSpPr>
-        <p:spPr>
-          <a:xfrm>
-            <a:off x="640080" y="1371600"/>
-            <a:ext cx="10908792" cy="3840480"/>
-          </a:xfrm>
-          <a:prstGeom prst="rect">
-            <a:avLst/>
-          </a:prstGeom>
-          <a:noFill/>
-        </p:spPr>
-        <p:txBody>
-          <a:bodyPr wrap="square">
-            <a:spAutoFit/>
-          </a:bodyPr>
-          <a:lstStyle/>
+              <a:rPr sz="1800" b="1" i="0">
+                <a:solidFill>
+                  <a:srgbClr val="BFD8C2"/>
+                </a:solidFill>
+                <a:latin typeface="Calibri"/>
+              </a:rPr>
+              <a:t>THE FLAGSHIP</a:t>
+            </a:r>
+          </a:p>
           <a:p>
             <a:pPr>
-              <a:lnSpc>
-                <a:spcPct val="110000"/>
-              </a:lnSpc>
-              <a:spcAft>
-                <a:spcPts val="1200"/>
-              </a:spcAft>
+              <a:spcBef>
+                <a:spcPts val="800"/>
+              </a:spcBef>
             </a:pPr>
             <a:r>
-              <a:rPr sz="1800" b="1" i="0">
-                <a:solidFill>
-                  <a:srgbClr val="188038"/>
-                </a:solidFill>
-                <a:latin typeface="Calibri"/>
-              </a:rPr>
-              <a:t>•  </a:t>
-            </a:r>
-            <a:r>
-              <a:rPr sz="1800" b="0" i="0">
-                <a:solidFill>
-                  <a:srgbClr val="333333"/>
-                </a:solidFill>
-                <a:latin typeface="Calibri"/>
-              </a:rPr>
-              <a:t>DOES: explore a defined search space fast, document every step, archive the winner</a:t>
-            </a:r>
-          </a:p>
-          <a:p>
-            <a:pPr>
-              <a:lnSpc>
-                <a:spcPct val="110000"/>
-              </a:lnSpc>
-              <a:spcAft>
-                <a:spcPts val="1200"/>
-              </a:spcAft>
-            </a:pPr>
-            <a:r>
-              <a:rPr sz="1800" b="1" i="0">
-                <a:solidFill>
-                  <a:srgbClr val="188038"/>
-                </a:solidFill>
-                <a:latin typeface="Calibri"/>
-              </a:rPr>
-              <a:t>•  </a:t>
-            </a:r>
-            <a:r>
-              <a:rPr sz="1800" b="0" i="0">
-                <a:solidFill>
-                  <a:srgbClr val="333333"/>
-                </a:solidFill>
-                <a:latin typeface="Calibri"/>
-              </a:rPr>
-              <a:t>DOESN'T: choose your scientific question, your loss, or your validity criteria — you do</a:t>
-            </a:r>
-          </a:p>
-          <a:p>
-            <a:pPr>
-              <a:lnSpc>
-                <a:spcPct val="110000"/>
-              </a:lnSpc>
-              <a:spcAft>
-                <a:spcPts val="1200"/>
-              </a:spcAft>
-            </a:pPr>
-            <a:r>
-              <a:rPr sz="1800" b="1" i="0">
-                <a:solidFill>
-                  <a:srgbClr val="188038"/>
-                </a:solidFill>
-                <a:latin typeface="Calibri"/>
-              </a:rPr>
-              <a:t>•  </a:t>
-            </a:r>
-            <a:r>
-              <a:rPr sz="1800" b="0" i="0">
-                <a:solidFill>
-                  <a:srgbClr val="333333"/>
-                </a:solidFill>
-                <a:latin typeface="Calibri"/>
-              </a:rPr>
-              <a:t>Guardrails: composite-metric fingerprint detects mid-project goal rewrites</a:t>
-            </a:r>
-          </a:p>
-          <a:p>
-            <a:pPr>
-              <a:lnSpc>
-                <a:spcPct val="110000"/>
-              </a:lnSpc>
-              <a:spcAft>
-                <a:spcPts val="1200"/>
-              </a:spcAft>
-            </a:pPr>
-            <a:r>
-              <a:rPr sz="1800" b="1" i="0">
-                <a:solidFill>
-                  <a:srgbClr val="188038"/>
-                </a:solidFill>
-                <a:latin typeface="Calibri"/>
-              </a:rPr>
-              <a:t>•  </a:t>
-            </a:r>
-            <a:r>
-              <a:rPr sz="1800" b="0" i="0">
-                <a:solidFill>
-                  <a:srgbClr val="333333"/>
-                </a:solidFill>
-                <a:latin typeface="Calibri"/>
-              </a:rPr>
-              <a:t>Reproducibility: deterministic seeds; crash-recovery checkpoints</a:t>
-            </a:r>
-          </a:p>
-          <a:p>
-            <a:pPr>
-              <a:lnSpc>
-                <a:spcPct val="110000"/>
-              </a:lnSpc>
-              <a:spcAft>
-                <a:spcPts val="1200"/>
-              </a:spcAft>
-            </a:pPr>
-            <a:r>
-              <a:rPr sz="1800" b="1" i="0">
-                <a:solidFill>
-                  <a:srgbClr val="188038"/>
-                </a:solidFill>
-                <a:latin typeface="Calibri"/>
-              </a:rPr>
-              <a:t>•  </a:t>
-            </a:r>
-            <a:r>
-              <a:rPr sz="1800" b="0" i="0">
-                <a:solidFill>
-                  <a:srgbClr val="333333"/>
-                </a:solidFill>
-                <a:latin typeface="Calibri"/>
-              </a:rPr>
-              <a:t>Output is a draft to review, not a paper to trust blindly</a:t>
-            </a:r>
-          </a:p>
-        </p:txBody>
-      </p:sp>
-      <p:sp>
-        <p:nvSpPr>
-          <p:cNvPr id="5" name="TextBox 4"/>
-          <p:cNvSpPr txBox="1"/>
-          <p:nvPr/>
-        </p:nvSpPr>
-        <p:spPr>
-          <a:xfrm>
-            <a:off x="640080" y="5349240"/>
-            <a:ext cx="10908792" cy="640080"/>
-          </a:xfrm>
-          <a:prstGeom prst="rect">
-            <a:avLst/>
-          </a:prstGeom>
-          <a:noFill/>
-        </p:spPr>
-        <p:txBody>
-          <a:bodyPr wrap="square">
-            <a:spAutoFit/>
-          </a:bodyPr>
-          <a:lstStyle/>
-          <a:p>
-            <a:r>
-              <a:rPr sz="1100" b="0" i="1">
-                <a:solidFill>
-                  <a:srgbClr val="9AA0A6"/>
-                </a:solidFill>
-                <a:latin typeface="Calibri"/>
-              </a:rPr>
-              <a:t>[Visual placeholder] A two-column "DOES / DOESN'T" card; a small lock icon for the metric-fingerprint guardrail.</a:t>
-            </a:r>
-          </a:p>
-        </p:txBody>
-      </p:sp>
-      <p:sp>
-        <p:nvSpPr>
-          <p:cNvPr id="6" name="TextBox 5"/>
-          <p:cNvSpPr txBox="1"/>
-          <p:nvPr/>
-        </p:nvSpPr>
-        <p:spPr>
-          <a:xfrm>
-            <a:off x="640080" y="5989320"/>
-            <a:ext cx="10908792" cy="640080"/>
-          </a:xfrm>
-          <a:prstGeom prst="rect">
-            <a:avLst/>
-          </a:prstGeom>
-          <a:noFill/>
-        </p:spPr>
-        <p:txBody>
-          <a:bodyPr wrap="square" anchor="ctr">
-            <a:spAutoFit/>
-          </a:bodyPr>
-          <a:lstStyle/>
-          <a:p>
-            <a:r>
-              <a:rPr sz="1600" b="1" i="0">
-                <a:solidFill>
-                  <a:srgbClr val="188038"/>
-                </a:solidFill>
-                <a:latin typeface="Calibri"/>
-              </a:rPr>
-              <a:t>TAKEAWAY: Autoresearch searches the space you define — it never defines the question.</a:t>
+              <a:rPr sz="3400" b="1" i="0">
+                <a:solidFill>
+                  <a:srgbClr val="FFFFFF"/>
+                </a:solidFill>
+                <a:latin typeface="Calibri"/>
+              </a:rPr>
+              <a:t>An autonomous research loop — Exp05</a:t>
             </a:r>
           </a:p>
         </p:txBody>
@@ -6462,21 +6772,45 @@
                 </a:solidFill>
                 <a:latin typeface="Calibri"/>
               </a:rPr>
-              <a:t>Challenges &amp; rigor: keeping the human in the loop</a:t>
-            </a:r>
-          </a:p>
-        </p:txBody>
-      </p:sp>
-      <p:sp>
-        <p:nvSpPr>
-          <p:cNvPr id="4" name="TextBox 3"/>
+              <a:t>The flagship: an autonomous research loop — Exp05</a:t>
+            </a:r>
+          </a:p>
+        </p:txBody>
+      </p:sp>
+      <p:pic>
+        <p:nvPicPr>
+          <p:cNvPr id="4" name="Picture 3" descr="champion_progress.png"/>
+          <p:cNvPicPr>
+            <a:picLocks noChangeAspect="1"/>
+          </p:cNvPicPr>
+          <p:nvPr/>
+        </p:nvPicPr>
+        <p:blipFill>
+          <a:blip r:embed="rId2"/>
+          <a:stretch>
+            <a:fillRect/>
+          </a:stretch>
+        </p:blipFill>
+        <p:spPr>
+          <a:xfrm>
+            <a:off x="6446520" y="2150693"/>
+            <a:ext cx="5029200" cy="2922373"/>
+          </a:xfrm>
+          <a:prstGeom prst="rect">
+            <a:avLst/>
+          </a:prstGeom>
+        </p:spPr>
+      </p:pic>
+      <p:sp>
+        <p:nvSpPr>
+          <p:cNvPr id="5" name="TextBox 4"/>
           <p:cNvSpPr txBox="1"/>
           <p:nvPr/>
         </p:nvSpPr>
         <p:spPr>
           <a:xfrm>
             <a:off x="640080" y="1371600"/>
-            <a:ext cx="10908792" cy="3840480"/>
+            <a:ext cx="5440680" cy="3840480"/>
           </a:xfrm>
           <a:prstGeom prst="rect">
             <a:avLst/>
@@ -6498,7 +6832,7 @@
               </a:spcAft>
             </a:pPr>
             <a:r>
-              <a:rPr sz="1800" b="1" i="0">
+              <a:rPr sz="1600" b="1" i="0">
                 <a:solidFill>
                   <a:srgbClr val="188038"/>
                 </a:solidFill>
@@ -6507,13 +6841,13 @@
               <a:t>•  </a:t>
             </a:r>
             <a:r>
-              <a:rPr sz="1800" b="0" i="0">
+              <a:rPr sz="1600" b="0" i="0">
                 <a:solidFill>
                   <a:srgbClr val="333333"/>
                 </a:solidFill>
                 <a:latin typeface="Calibri"/>
               </a:rPr>
-              <a:t>Leakage &amp; look-ahead: the most common failure — enforce chronological/spatial splits</a:t>
+              <a:t>The agent is the researcher: Diagnose → Cite → Hypothesize → Predict → Execute → Analyze → Checkpoint</a:t>
             </a:r>
           </a:p>
           <a:p>
@@ -6526,7 +6860,7 @@
               </a:spcAft>
             </a:pPr>
             <a:r>
-              <a:rPr sz="1800" b="1" i="0">
+              <a:rPr sz="1600" b="1" i="0">
                 <a:solidFill>
                   <a:srgbClr val="188038"/>
                 </a:solidFill>
@@ -6535,13 +6869,13 @@
               <a:t>•  </a:t>
             </a:r>
             <a:r>
-              <a:rPr sz="1800" b="0" i="0">
+              <a:rPr sz="1600" b="0" i="0">
                 <a:solidFill>
                   <a:srgbClr val="333333"/>
                 </a:solidFill>
                 <a:latin typeface="Calibri"/>
               </a:rPr>
-              <a:t>Multiple testing across many stations/species/cells — correct for it</a:t>
+              <a:t>Hard gates before any run: citation-rigor + reasoning-completeness (no ungrounded experiments)</a:t>
             </a:r>
           </a:p>
           <a:p>
@@ -6554,7 +6888,7 @@
               </a:spcAft>
             </a:pPr>
             <a:r>
-              <a:rPr sz="1800" b="1" i="0">
+              <a:rPr sz="1600" b="1" i="0">
                 <a:solidFill>
                   <a:srgbClr val="188038"/>
                 </a:solidFill>
@@ -6563,13 +6897,13 @@
               <a:t>•  </a:t>
             </a:r>
             <a:r>
-              <a:rPr sz="1800" b="0" i="0">
+              <a:rPr sz="1600" b="0" i="0">
                 <a:solidFill>
                   <a:srgbClr val="333333"/>
                 </a:solidFill>
                 <a:latin typeface="Calibri"/>
               </a:rPr>
-              <a:t>Uncertainty is mandatory: report intervals, not point estimates</a:t>
+              <a:t>Gated 6-experiment loop ran in ~38 s; champion +8.0% skill (RMSE 1.95→1.79 °C), monotone composite</a:t>
             </a:r>
           </a:p>
           <a:p>
@@ -6582,7 +6916,7 @@
               </a:spcAft>
             </a:pPr>
             <a:r>
-              <a:rPr sz="1800" b="1" i="0">
+              <a:rPr sz="1600" b="1" i="0">
                 <a:solidFill>
                   <a:srgbClr val="188038"/>
                 </a:solidFill>
@@ -6591,13 +6925,13 @@
               <a:t>•  </a:t>
             </a:r>
             <a:r>
-              <a:rPr sz="1800" b="0" i="0">
+              <a:rPr sz="1600" b="0" i="0">
                 <a:solidFill>
                   <a:srgbClr val="333333"/>
                 </a:solidFill>
                 <a:latin typeface="Calibri"/>
               </a:rPr>
-              <a:t>Hallucinated citations / numbers — verify; quarantine the unverified (ledgers/CITATIONS-TO-VERIFY.md)</a:t>
+              <a:t>Adapted from the user's own dlmastery/autoresearch (generalized_ml_autoresearch)</a:t>
             </a:r>
           </a:p>
           <a:p>
@@ -6610,7 +6944,7 @@
               </a:spcAft>
             </a:pPr>
             <a:r>
-              <a:rPr sz="1800" b="1" i="0">
+              <a:rPr sz="1600" b="1" i="0">
                 <a:solidFill>
                   <a:srgbClr val="188038"/>
                 </a:solidFill>
@@ -6619,27 +6953,27 @@
               <a:t>•  </a:t>
             </a:r>
             <a:r>
-              <a:rPr sz="1800" b="0" i="0">
+              <a:rPr sz="1600" b="0" i="0">
                 <a:solidFill>
                   <a:srgbClr val="333333"/>
                 </a:solidFill>
                 <a:latin typeface="Calibri"/>
               </a:rPr>
-              <a:t>Reproducibility: seeds, committed results, runs-anywhere on synthetic data</a:t>
-            </a:r>
-          </a:p>
-        </p:txBody>
-      </p:sp>
-      <p:sp>
-        <p:nvSpPr>
-          <p:cNvPr id="5" name="TextBox 4"/>
+              <a:t>Pluggable backbones / splits / composite metric; champion archive + research journal; runs on one 4090</a:t>
+            </a:r>
+          </a:p>
+        </p:txBody>
+      </p:sp>
+      <p:sp>
+        <p:nvSpPr>
+          <p:cNvPr id="6" name="TextBox 5"/>
           <p:cNvSpPr txBox="1"/>
           <p:nvPr/>
         </p:nvSpPr>
         <p:spPr>
           <a:xfrm>
-            <a:off x="640080" y="5349240"/>
-            <a:ext cx="10908792" cy="640080"/>
+            <a:off x="640080" y="5440680"/>
+            <a:ext cx="5440680" cy="548640"/>
           </a:xfrm>
           <a:prstGeom prst="rect">
             <a:avLst/>
@@ -6653,20 +6987,20 @@
           <a:lstStyle/>
           <a:p>
             <a:r>
-              <a:rPr sz="1100" b="0" i="1">
+              <a:rPr sz="1000" b="0" i="1">
                 <a:solidFill>
                   <a:srgbClr val="9AA0A6"/>
                 </a:solidFill>
                 <a:latin typeface="Calibri"/>
               </a:rPr>
-              <a:t>[Visual placeholder] A "human-in-the-loop" diagram: agent proposes → human checks the five risk items → accept/reject; the five items listed as a checklist.</a:t>
-            </a:r>
-          </a:p>
-        </p:txBody>
-      </p:sp>
-      <p:sp>
-        <p:nvSpPr>
-          <p:cNvPr id="6" name="TextBox 5"/>
+              <a:t>[Figure: committed result] The 7-step loop as a circle with the two hard gates drawn as locks before "Execute"; a thumbnail of the champion-archive folder + research-journal entry. Reference docs/autoresearch_protocol.md.</a:t>
+            </a:r>
+          </a:p>
+        </p:txBody>
+      </p:sp>
+      <p:sp>
+        <p:nvSpPr>
+          <p:cNvPr id="7" name="TextBox 6"/>
           <p:cNvSpPr txBox="1"/>
           <p:nvPr/>
         </p:nvSpPr>
@@ -6693,7 +7027,7 @@
                 </a:solidFill>
                 <a:latin typeface="Calibri"/>
               </a:rPr>
-              <a:t>TAKEAWAY: The human owns five checks — leakage, multiplicity, uncertainty, citations, reproducibility.</a:t>
+              <a:t>TAKEAWAY: The loop makes the agent a researcher — gated so it can't fish for significance.</a:t>
             </a:r>
           </a:p>
         </p:txBody>
@@ -6797,7 +7131,7 @@
                 </a:solidFill>
                 <a:latin typeface="Calibri"/>
               </a:rPr>
-              <a:t>What you can do Monday</a:t>
+              <a:t>Autoresearch, honestly: what it does and doesn't do</a:t>
             </a:r>
           </a:p>
         </p:txBody>
@@ -6848,7 +7182,7 @@
                 </a:solidFill>
                 <a:latin typeface="Calibri"/>
               </a:rPr>
-              <a:t>Today: install Claude Code; ask it to reproduce one figure from your last paper</a:t>
+              <a:t>DOES: explore a defined search space fast, document every step, archive the winner</a:t>
             </a:r>
           </a:p>
           <a:p>
@@ -6876,7 +7210,7 @@
                 </a:solidFill>
                 <a:latin typeface="Calibri"/>
               </a:rPr>
-              <a:t>This week: hand it a full small pipeline — "fetch ERA5, fit a trend, validate, plot"</a:t>
+              <a:t>DOESN'T: choose your scientific question, your loss, or your validity criteria — you do</a:t>
             </a:r>
           </a:p>
           <a:p>
@@ -6904,7 +7238,7 @@
                 </a:solidFill>
                 <a:latin typeface="Calibri"/>
               </a:rPr>
-              <a:t>This month: write one skill that encodes your group's validation conventions</a:t>
+              <a:t>Guardrails: composite-metric fingerprint detects mid-project goal rewrites</a:t>
             </a:r>
           </a:p>
           <a:p>
@@ -6932,7 +7266,7 @@
                 </a:solidFill>
                 <a:latin typeface="Calibri"/>
               </a:rPr>
-              <a:t>Start on synthetic / small public data — no keys, no GPU — then scale up</a:t>
+              <a:t>Reproducibility: deterministic seeds; crash-recovery checkpoints</a:t>
             </a:r>
           </a:p>
           <a:p>
@@ -6960,7 +7294,7 @@
                 </a:solidFill>
                 <a:latin typeface="Calibri"/>
               </a:rPr>
-              <a:t>Clone this repo and run experiments/01_.../run_before_after.py as your template</a:t>
+              <a:t>Output is a draft to review, not a paper to trust blindly</a:t>
             </a:r>
           </a:p>
         </p:txBody>
@@ -6994,7 +7328,7 @@
                 </a:solidFill>
                 <a:latin typeface="Calibri"/>
               </a:rPr>
-              <a:t>[Visual placeholder] A three-step "Today / This week / This month" timeline card mirroring the handout; a small QR placeholder to the repo.</a:t>
+              <a:t>[Visual placeholder] A two-column "DOES / DOESN'T" card; a small lock icon for the metric-fingerprint guardrail.</a:t>
             </a:r>
           </a:p>
         </p:txBody>
@@ -7028,7 +7362,7 @@
                 </a:solidFill>
                 <a:latin typeface="Calibri"/>
               </a:rPr>
-              <a:t>TAKEAWAY: You can start today on synthetic data — no keys, no GPU required.</a:t>
+              <a:t>TAKEAWAY: Autoresearch searches the space you define — it never defines the question.</a:t>
             </a:r>
           </a:p>
         </p:txBody>
@@ -7132,7 +7466,7 @@
                 </a:solidFill>
                 <a:latin typeface="Calibri"/>
               </a:rPr>
-              <a:t>Vision: the 100×-faster lab</a:t>
+              <a:t>Challenges &amp; rigor: keeping the human in the loop</a:t>
             </a:r>
           </a:p>
         </p:txBody>
@@ -7183,7 +7517,7 @@
                 </a:solidFill>
                 <a:latin typeface="Calibri"/>
               </a:rPr>
-              <a:t>The scarce resource becomes good questions and good judgment, not labor</a:t>
+              <a:t>Leakage &amp; look-ahead: the most common failure — enforce chronological/spatial splits</a:t>
             </a:r>
           </a:p>
           <a:p>
@@ -7211,7 +7545,7 @@
                 </a:solidFill>
                 <a:latin typeface="Calibri"/>
               </a:rPr>
-              <a:t>Each scientist runs a small team of agents; reproducibility and audit trails improve, not degrade</a:t>
+              <a:t>Multiple testing across many stations/species/cells — correct for it</a:t>
             </a:r>
           </a:p>
           <a:p>
@@ -7239,7 +7573,7 @@
                 </a:solidFill>
                 <a:latin typeface="Calibri"/>
               </a:rPr>
-              <a:t>Open data + desktop GPUs + agents → individual scientists doing institution-scale work</a:t>
+              <a:t>Uncertainty is mandatory: report intervals, not point estimates</a:t>
             </a:r>
           </a:p>
           <a:p>
@@ -7267,7 +7601,7 @@
                 </a:solidFill>
                 <a:latin typeface="Calibri"/>
               </a:rPr>
-              <a:t>The statistician's role grows: assumptions, validity, interpretation, communication</a:t>
+              <a:t>Hallucinated citations / numbers — verify; quarantine the unverified (ledgers/CITATIONS-TO-VERIFY.md)</a:t>
             </a:r>
           </a:p>
           <a:p>
@@ -7295,7 +7629,7 @@
                 </a:solidFill>
                 <a:latin typeface="Calibri"/>
               </a:rPr>
-              <a:t>The repo is the proof-of-concept; your lab is the next instance</a:t>
+              <a:t>Reproducibility: seeds, committed results, runs-anywhere on synthetic data</a:t>
             </a:r>
           </a:p>
         </p:txBody>
@@ -7329,7 +7663,7 @@
                 </a:solidFill>
                 <a:latin typeface="Calibri"/>
               </a:rPr>
-              <a:t>[Visual placeholder] A single scientist at a laptop with several "agent" worker icons fanning out to the taxonomy cells; calm, optimistic framing.</a:t>
+              <a:t>[Visual placeholder] A "human-in-the-loop" diagram: agent proposes → human checks the five risk items → accept/reject; the five items listed as a checklist.</a:t>
             </a:r>
           </a:p>
         </p:txBody>
@@ -7363,7 +7697,7 @@
                 </a:solidFill>
                 <a:latin typeface="Calibri"/>
               </a:rPr>
-              <a:t>TAKEAWAY: When labor is cheap, scientific judgment becomes the differentiator.</a:t>
+              <a:t>TAKEAWAY: The human owns five checks — leakage, multiplicity, uncertainty, citations, reproducibility.</a:t>
             </a:r>
           </a:p>
         </p:txBody>
@@ -7467,7 +7801,7 @@
                 </a:solidFill>
                 <a:latin typeface="Calibri"/>
               </a:rPr>
-              <a:t>Thank you · resources · reproduce everything</a:t>
+              <a:t>What you can do Monday</a:t>
             </a:r>
           </a:p>
         </p:txBody>
@@ -7518,7 +7852,7 @@
                 </a:solidFill>
                 <a:latin typeface="Calibri"/>
               </a:rPr>
-              <a:t>Repo: environment_stats_talk (companion code + committed results + this deck)</a:t>
+              <a:t>Today: install Claude Code; ask it to reproduce one figure from your last paper</a:t>
             </a:r>
           </a:p>
           <a:p>
@@ -7546,7 +7880,7 @@
                 </a:solidFill>
                 <a:latin typeface="Calibri"/>
               </a:rPr>
-              <a:t>Reproduce everything: python run_all_tests.py (tests) + each experiment's run_before_after.py</a:t>
+              <a:t>This week: hand it a full small pipeline — "fetch ERA5, fit a trend, validate, plot"</a:t>
             </a:r>
           </a:p>
           <a:p>
@@ -7574,7 +7908,7 @@
                 </a:solidFill>
                 <a:latin typeface="Calibri"/>
               </a:rPr>
-              <a:t>Verifiable anchors: ClimateLLM 2502.11059 · CLLMate 2409.19058 · AI co-scientist 2502.18864 · AI-Scientist-v2 2504.08066 · EagleVision 2503.23330</a:t>
+              <a:t>This month: write one skill that encodes your group's validation conventions</a:t>
             </a:r>
           </a:p>
           <a:p>
@@ -7602,7 +7936,7 @@
                 </a:solidFill>
                 <a:latin typeface="Calibri"/>
               </a:rPr>
-              <a:t>Datasets: ERA5 · GBIF · iNaturalist · Sentinel-2 · CAMELS · OpenAQ</a:t>
+              <a:t>Start on synthetic / small public data — no keys, no GPU — then scale up</a:t>
             </a:r>
           </a:p>
           <a:p>
@@ -7630,7 +7964,7 @@
                 </a:solidFill>
                 <a:latin typeface="Calibri"/>
               </a:rPr>
-              <a:t>Handout: docs/talk/handout.md (copy-paste prompts + action plan) · Contact: eranti@gmail.com</a:t>
+              <a:t>Clone this repo and run experiments/01_.../run_before_after.py as your template</a:t>
             </a:r>
           </a:p>
         </p:txBody>
@@ -7664,7 +7998,7 @@
                 </a:solidFill>
                 <a:latin typeface="Calibri"/>
               </a:rPr>
-              <a:t>[Visual placeholder] A clean resource card with the arXiv IDs and dataset names, a QR placeholder to the public repo, and contact info.</a:t>
+              <a:t>[Visual placeholder] A three-step "Today / This week / This month" timeline card mirroring the handout; a small QR placeholder to the repo.</a:t>
             </a:r>
           </a:p>
         </p:txBody>
@@ -7698,7 +8032,342 @@
                 </a:solidFill>
                 <a:latin typeface="Calibri"/>
               </a:rPr>
-              <a:t>TAKEAWAY: Take the handout, clone the repo, and try one prompt tonight.</a:t>
+              <a:t>TAKEAWAY: You can start today on synthetic data — no keys, no GPU required.</a:t>
+            </a:r>
+          </a:p>
+        </p:txBody>
+      </p:sp>
+    </p:spTree>
+  </p:cSld>
+  <p:clrMapOvr>
+    <a:masterClrMapping/>
+  </p:clrMapOvr>
+</p:sld>
+</file>
+
+<file path=ppt/slides/slide19.xml><?xml version="1.0" encoding="utf-8"?>
+<p:sld xmlns:a="http://schemas.openxmlformats.org/drawingml/2006/main" xmlns:p="http://schemas.openxmlformats.org/presentationml/2006/main" xmlns:r="http://schemas.openxmlformats.org/officeDocument/2006/relationships">
+  <p:cSld>
+    <p:bg>
+      <p:bgPr>
+        <a:solidFill>
+          <a:srgbClr val="FFFFFF"/>
+        </a:solidFill>
+        <a:effectLst/>
+      </p:bgPr>
+    </p:bg>
+    <p:spTree>
+      <p:nvGrpSpPr>
+        <p:cNvPr id="1" name=""/>
+        <p:cNvGrpSpPr/>
+        <p:nvPr/>
+      </p:nvGrpSpPr>
+      <p:grpSpPr/>
+      <p:sp>
+        <p:nvSpPr>
+          <p:cNvPr id="2" name="Rectangle 1"/>
+          <p:cNvSpPr/>
+          <p:nvPr/>
+        </p:nvSpPr>
+        <p:spPr>
+          <a:xfrm>
+            <a:off x="0" y="0"/>
+            <a:ext cx="12191695" cy="146304"/>
+          </a:xfrm>
+          <a:prstGeom prst="rect">
+            <a:avLst/>
+          </a:prstGeom>
+          <a:solidFill>
+            <a:srgbClr val="1A3A5C"/>
+          </a:solidFill>
+          <a:ln>
+            <a:noFill/>
+          </a:ln>
+          <a:effectLst/>
+        </p:spPr>
+        <p:style>
+          <a:lnRef idx="1">
+            <a:schemeClr val="accent1"/>
+          </a:lnRef>
+          <a:fillRef idx="3">
+            <a:schemeClr val="accent1"/>
+          </a:fillRef>
+          <a:effectRef idx="2">
+            <a:schemeClr val="accent1"/>
+          </a:effectRef>
+          <a:fontRef idx="minor">
+            <a:schemeClr val="lt1"/>
+          </a:fontRef>
+        </p:style>
+        <p:txBody>
+          <a:bodyPr rtlCol="0" anchor="ctr"/>
+          <a:lstStyle/>
+          <a:p>
+            <a:pPr algn="ctr"/>
+          </a:p>
+        </p:txBody>
+      </p:sp>
+      <p:sp>
+        <p:nvSpPr>
+          <p:cNvPr id="3" name="TextBox 2"/>
+          <p:cNvSpPr txBox="1"/>
+          <p:nvPr/>
+        </p:nvSpPr>
+        <p:spPr>
+          <a:xfrm>
+            <a:off x="640080" y="292608"/>
+            <a:ext cx="10908792" cy="914400"/>
+          </a:xfrm>
+          <a:prstGeom prst="rect">
+            <a:avLst/>
+          </a:prstGeom>
+          <a:noFill/>
+        </p:spPr>
+        <p:txBody>
+          <a:bodyPr wrap="square">
+            <a:spAutoFit/>
+          </a:bodyPr>
+          <a:lstStyle/>
+          <a:p>
+            <a:r>
+              <a:rPr sz="2800" b="1" i="0">
+                <a:solidFill>
+                  <a:srgbClr val="1A3A5C"/>
+                </a:solidFill>
+                <a:latin typeface="Calibri"/>
+              </a:rPr>
+              <a:t>Vision: the 100×-faster lab</a:t>
+            </a:r>
+          </a:p>
+        </p:txBody>
+      </p:sp>
+      <p:sp>
+        <p:nvSpPr>
+          <p:cNvPr id="4" name="TextBox 3"/>
+          <p:cNvSpPr txBox="1"/>
+          <p:nvPr/>
+        </p:nvSpPr>
+        <p:spPr>
+          <a:xfrm>
+            <a:off x="640080" y="1371600"/>
+            <a:ext cx="10908792" cy="3840480"/>
+          </a:xfrm>
+          <a:prstGeom prst="rect">
+            <a:avLst/>
+          </a:prstGeom>
+          <a:noFill/>
+        </p:spPr>
+        <p:txBody>
+          <a:bodyPr wrap="square">
+            <a:spAutoFit/>
+          </a:bodyPr>
+          <a:lstStyle/>
+          <a:p>
+            <a:pPr>
+              <a:lnSpc>
+                <a:spcPct val="110000"/>
+              </a:lnSpc>
+              <a:spcAft>
+                <a:spcPts val="1200"/>
+              </a:spcAft>
+            </a:pPr>
+            <a:r>
+              <a:rPr sz="1800" b="1" i="0">
+                <a:solidFill>
+                  <a:srgbClr val="188038"/>
+                </a:solidFill>
+                <a:latin typeface="Calibri"/>
+              </a:rPr>
+              <a:t>•  </a:t>
+            </a:r>
+            <a:r>
+              <a:rPr sz="1800" b="0" i="0">
+                <a:solidFill>
+                  <a:srgbClr val="333333"/>
+                </a:solidFill>
+                <a:latin typeface="Calibri"/>
+              </a:rPr>
+              <a:t>The scarce resource becomes good questions and good judgment, not labor</a:t>
+            </a:r>
+          </a:p>
+          <a:p>
+            <a:pPr>
+              <a:lnSpc>
+                <a:spcPct val="110000"/>
+              </a:lnSpc>
+              <a:spcAft>
+                <a:spcPts val="1200"/>
+              </a:spcAft>
+            </a:pPr>
+            <a:r>
+              <a:rPr sz="1800" b="1" i="0">
+                <a:solidFill>
+                  <a:srgbClr val="188038"/>
+                </a:solidFill>
+                <a:latin typeface="Calibri"/>
+              </a:rPr>
+              <a:t>•  </a:t>
+            </a:r>
+            <a:r>
+              <a:rPr sz="1800" b="0" i="0">
+                <a:solidFill>
+                  <a:srgbClr val="333333"/>
+                </a:solidFill>
+                <a:latin typeface="Calibri"/>
+              </a:rPr>
+              <a:t>Each scientist runs a small team of agents; reproducibility and audit trails improve, not degrade</a:t>
+            </a:r>
+          </a:p>
+          <a:p>
+            <a:pPr>
+              <a:lnSpc>
+                <a:spcPct val="110000"/>
+              </a:lnSpc>
+              <a:spcAft>
+                <a:spcPts val="1200"/>
+              </a:spcAft>
+            </a:pPr>
+            <a:r>
+              <a:rPr sz="1800" b="1" i="0">
+                <a:solidFill>
+                  <a:srgbClr val="188038"/>
+                </a:solidFill>
+                <a:latin typeface="Calibri"/>
+              </a:rPr>
+              <a:t>•  </a:t>
+            </a:r>
+            <a:r>
+              <a:rPr sz="1800" b="0" i="0">
+                <a:solidFill>
+                  <a:srgbClr val="333333"/>
+                </a:solidFill>
+                <a:latin typeface="Calibri"/>
+              </a:rPr>
+              <a:t>Open data + desktop GPUs + agents → individual scientists doing institution-scale work</a:t>
+            </a:r>
+          </a:p>
+          <a:p>
+            <a:pPr>
+              <a:lnSpc>
+                <a:spcPct val="110000"/>
+              </a:lnSpc>
+              <a:spcAft>
+                <a:spcPts val="1200"/>
+              </a:spcAft>
+            </a:pPr>
+            <a:r>
+              <a:rPr sz="1800" b="1" i="0">
+                <a:solidFill>
+                  <a:srgbClr val="188038"/>
+                </a:solidFill>
+                <a:latin typeface="Calibri"/>
+              </a:rPr>
+              <a:t>•  </a:t>
+            </a:r>
+            <a:r>
+              <a:rPr sz="1800" b="0" i="0">
+                <a:solidFill>
+                  <a:srgbClr val="333333"/>
+                </a:solidFill>
+                <a:latin typeface="Calibri"/>
+              </a:rPr>
+              <a:t>The statistician's role grows: assumptions, validity, interpretation, communication</a:t>
+            </a:r>
+          </a:p>
+          <a:p>
+            <a:pPr>
+              <a:lnSpc>
+                <a:spcPct val="110000"/>
+              </a:lnSpc>
+              <a:spcAft>
+                <a:spcPts val="1200"/>
+              </a:spcAft>
+            </a:pPr>
+            <a:r>
+              <a:rPr sz="1800" b="1" i="0">
+                <a:solidFill>
+                  <a:srgbClr val="188038"/>
+                </a:solidFill>
+                <a:latin typeface="Calibri"/>
+              </a:rPr>
+              <a:t>•  </a:t>
+            </a:r>
+            <a:r>
+              <a:rPr sz="1800" b="0" i="0">
+                <a:solidFill>
+                  <a:srgbClr val="333333"/>
+                </a:solidFill>
+                <a:latin typeface="Calibri"/>
+              </a:rPr>
+              <a:t>The repo is the proof-of-concept; your lab is the next instance</a:t>
+            </a:r>
+          </a:p>
+        </p:txBody>
+      </p:sp>
+      <p:sp>
+        <p:nvSpPr>
+          <p:cNvPr id="5" name="TextBox 4"/>
+          <p:cNvSpPr txBox="1"/>
+          <p:nvPr/>
+        </p:nvSpPr>
+        <p:spPr>
+          <a:xfrm>
+            <a:off x="640080" y="5349240"/>
+            <a:ext cx="10908792" cy="640080"/>
+          </a:xfrm>
+          <a:prstGeom prst="rect">
+            <a:avLst/>
+          </a:prstGeom>
+          <a:noFill/>
+        </p:spPr>
+        <p:txBody>
+          <a:bodyPr wrap="square">
+            <a:spAutoFit/>
+          </a:bodyPr>
+          <a:lstStyle/>
+          <a:p>
+            <a:r>
+              <a:rPr sz="1100" b="0" i="1">
+                <a:solidFill>
+                  <a:srgbClr val="9AA0A6"/>
+                </a:solidFill>
+                <a:latin typeface="Calibri"/>
+              </a:rPr>
+              <a:t>[Visual placeholder] A single scientist at a laptop with several "agent" worker icons fanning out to the taxonomy cells; calm, optimistic framing.</a:t>
+            </a:r>
+          </a:p>
+        </p:txBody>
+      </p:sp>
+      <p:sp>
+        <p:nvSpPr>
+          <p:cNvPr id="6" name="TextBox 5"/>
+          <p:cNvSpPr txBox="1"/>
+          <p:nvPr/>
+        </p:nvSpPr>
+        <p:spPr>
+          <a:xfrm>
+            <a:off x="640080" y="5989320"/>
+            <a:ext cx="10908792" cy="640080"/>
+          </a:xfrm>
+          <a:prstGeom prst="rect">
+            <a:avLst/>
+          </a:prstGeom>
+          <a:noFill/>
+        </p:spPr>
+        <p:txBody>
+          <a:bodyPr wrap="square" anchor="ctr">
+            <a:spAutoFit/>
+          </a:bodyPr>
+          <a:lstStyle/>
+          <a:p>
+            <a:r>
+              <a:rPr sz="1600" b="1" i="0">
+                <a:solidFill>
+                  <a:srgbClr val="188038"/>
+                </a:solidFill>
+                <a:latin typeface="Calibri"/>
+              </a:rPr>
+              <a:t>TAKEAWAY: When labor is cheap, scientific judgment becomes the differentiator.</a:t>
             </a:r>
           </a:p>
         </p:txBody>
@@ -8046,6 +8715,341 @@
 </p:sld>
 </file>
 
+<file path=ppt/slides/slide20.xml><?xml version="1.0" encoding="utf-8"?>
+<p:sld xmlns:a="http://schemas.openxmlformats.org/drawingml/2006/main" xmlns:p="http://schemas.openxmlformats.org/presentationml/2006/main" xmlns:r="http://schemas.openxmlformats.org/officeDocument/2006/relationships">
+  <p:cSld>
+    <p:bg>
+      <p:bgPr>
+        <a:solidFill>
+          <a:srgbClr val="FFFFFF"/>
+        </a:solidFill>
+        <a:effectLst/>
+      </p:bgPr>
+    </p:bg>
+    <p:spTree>
+      <p:nvGrpSpPr>
+        <p:cNvPr id="1" name=""/>
+        <p:cNvGrpSpPr/>
+        <p:nvPr/>
+      </p:nvGrpSpPr>
+      <p:grpSpPr/>
+      <p:sp>
+        <p:nvSpPr>
+          <p:cNvPr id="2" name="Rectangle 1"/>
+          <p:cNvSpPr/>
+          <p:nvPr/>
+        </p:nvSpPr>
+        <p:spPr>
+          <a:xfrm>
+            <a:off x="0" y="0"/>
+            <a:ext cx="12191695" cy="146304"/>
+          </a:xfrm>
+          <a:prstGeom prst="rect">
+            <a:avLst/>
+          </a:prstGeom>
+          <a:solidFill>
+            <a:srgbClr val="1A3A5C"/>
+          </a:solidFill>
+          <a:ln>
+            <a:noFill/>
+          </a:ln>
+          <a:effectLst/>
+        </p:spPr>
+        <p:style>
+          <a:lnRef idx="1">
+            <a:schemeClr val="accent1"/>
+          </a:lnRef>
+          <a:fillRef idx="3">
+            <a:schemeClr val="accent1"/>
+          </a:fillRef>
+          <a:effectRef idx="2">
+            <a:schemeClr val="accent1"/>
+          </a:effectRef>
+          <a:fontRef idx="minor">
+            <a:schemeClr val="lt1"/>
+          </a:fontRef>
+        </p:style>
+        <p:txBody>
+          <a:bodyPr rtlCol="0" anchor="ctr"/>
+          <a:lstStyle/>
+          <a:p>
+            <a:pPr algn="ctr"/>
+          </a:p>
+        </p:txBody>
+      </p:sp>
+      <p:sp>
+        <p:nvSpPr>
+          <p:cNvPr id="3" name="TextBox 2"/>
+          <p:cNvSpPr txBox="1"/>
+          <p:nvPr/>
+        </p:nvSpPr>
+        <p:spPr>
+          <a:xfrm>
+            <a:off x="640080" y="292608"/>
+            <a:ext cx="10908792" cy="914400"/>
+          </a:xfrm>
+          <a:prstGeom prst="rect">
+            <a:avLst/>
+          </a:prstGeom>
+          <a:noFill/>
+        </p:spPr>
+        <p:txBody>
+          <a:bodyPr wrap="square">
+            <a:spAutoFit/>
+          </a:bodyPr>
+          <a:lstStyle/>
+          <a:p>
+            <a:r>
+              <a:rPr sz="2800" b="1" i="0">
+                <a:solidFill>
+                  <a:srgbClr val="1A3A5C"/>
+                </a:solidFill>
+                <a:latin typeface="Calibri"/>
+              </a:rPr>
+              <a:t>Thank you · resources · reproduce everything</a:t>
+            </a:r>
+          </a:p>
+        </p:txBody>
+      </p:sp>
+      <p:sp>
+        <p:nvSpPr>
+          <p:cNvPr id="4" name="TextBox 3"/>
+          <p:cNvSpPr txBox="1"/>
+          <p:nvPr/>
+        </p:nvSpPr>
+        <p:spPr>
+          <a:xfrm>
+            <a:off x="640080" y="1371600"/>
+            <a:ext cx="10908792" cy="3840480"/>
+          </a:xfrm>
+          <a:prstGeom prst="rect">
+            <a:avLst/>
+          </a:prstGeom>
+          <a:noFill/>
+        </p:spPr>
+        <p:txBody>
+          <a:bodyPr wrap="square">
+            <a:spAutoFit/>
+          </a:bodyPr>
+          <a:lstStyle/>
+          <a:p>
+            <a:pPr>
+              <a:lnSpc>
+                <a:spcPct val="110000"/>
+              </a:lnSpc>
+              <a:spcAft>
+                <a:spcPts val="1200"/>
+              </a:spcAft>
+            </a:pPr>
+            <a:r>
+              <a:rPr sz="1800" b="1" i="0">
+                <a:solidFill>
+                  <a:srgbClr val="188038"/>
+                </a:solidFill>
+                <a:latin typeface="Calibri"/>
+              </a:rPr>
+              <a:t>•  </a:t>
+            </a:r>
+            <a:r>
+              <a:rPr sz="1800" b="0" i="0">
+                <a:solidFill>
+                  <a:srgbClr val="333333"/>
+                </a:solidFill>
+                <a:latin typeface="Calibri"/>
+              </a:rPr>
+              <a:t>Repo: environment_stats_talk (companion code + committed results + this deck)</a:t>
+            </a:r>
+          </a:p>
+          <a:p>
+            <a:pPr>
+              <a:lnSpc>
+                <a:spcPct val="110000"/>
+              </a:lnSpc>
+              <a:spcAft>
+                <a:spcPts val="1200"/>
+              </a:spcAft>
+            </a:pPr>
+            <a:r>
+              <a:rPr sz="1800" b="1" i="0">
+                <a:solidFill>
+                  <a:srgbClr val="188038"/>
+                </a:solidFill>
+                <a:latin typeface="Calibri"/>
+              </a:rPr>
+              <a:t>•  </a:t>
+            </a:r>
+            <a:r>
+              <a:rPr sz="1800" b="0" i="0">
+                <a:solidFill>
+                  <a:srgbClr val="333333"/>
+                </a:solidFill>
+                <a:latin typeface="Calibri"/>
+              </a:rPr>
+              <a:t>Reproduce everything: python run_all_tests.py (tests) + each experiment's run_before_after.py</a:t>
+            </a:r>
+          </a:p>
+          <a:p>
+            <a:pPr>
+              <a:lnSpc>
+                <a:spcPct val="110000"/>
+              </a:lnSpc>
+              <a:spcAft>
+                <a:spcPts val="1200"/>
+              </a:spcAft>
+            </a:pPr>
+            <a:r>
+              <a:rPr sz="1800" b="1" i="0">
+                <a:solidFill>
+                  <a:srgbClr val="188038"/>
+                </a:solidFill>
+                <a:latin typeface="Calibri"/>
+              </a:rPr>
+              <a:t>•  </a:t>
+            </a:r>
+            <a:r>
+              <a:rPr sz="1800" b="0" i="0">
+                <a:solidFill>
+                  <a:srgbClr val="333333"/>
+                </a:solidFill>
+                <a:latin typeface="Calibri"/>
+              </a:rPr>
+              <a:t>Verifiable anchors: ClimateLLM 2502.11059 · CLLMate 2409.19058 · AI co-scientist 2502.18864 · AI-Scientist-v2 2504.08066 · EagleVision 2503.23330</a:t>
+            </a:r>
+          </a:p>
+          <a:p>
+            <a:pPr>
+              <a:lnSpc>
+                <a:spcPct val="110000"/>
+              </a:lnSpc>
+              <a:spcAft>
+                <a:spcPts val="1200"/>
+              </a:spcAft>
+            </a:pPr>
+            <a:r>
+              <a:rPr sz="1800" b="1" i="0">
+                <a:solidFill>
+                  <a:srgbClr val="188038"/>
+                </a:solidFill>
+                <a:latin typeface="Calibri"/>
+              </a:rPr>
+              <a:t>•  </a:t>
+            </a:r>
+            <a:r>
+              <a:rPr sz="1800" b="0" i="0">
+                <a:solidFill>
+                  <a:srgbClr val="333333"/>
+                </a:solidFill>
+                <a:latin typeface="Calibri"/>
+              </a:rPr>
+              <a:t>Datasets: ERA5 · GBIF · iNaturalist · Sentinel-2 · CAMELS · OpenAQ</a:t>
+            </a:r>
+          </a:p>
+          <a:p>
+            <a:pPr>
+              <a:lnSpc>
+                <a:spcPct val="110000"/>
+              </a:lnSpc>
+              <a:spcAft>
+                <a:spcPts val="1200"/>
+              </a:spcAft>
+            </a:pPr>
+            <a:r>
+              <a:rPr sz="1800" b="1" i="0">
+                <a:solidFill>
+                  <a:srgbClr val="188038"/>
+                </a:solidFill>
+                <a:latin typeface="Calibri"/>
+              </a:rPr>
+              <a:t>•  </a:t>
+            </a:r>
+            <a:r>
+              <a:rPr sz="1800" b="0" i="0">
+                <a:solidFill>
+                  <a:srgbClr val="333333"/>
+                </a:solidFill>
+                <a:latin typeface="Calibri"/>
+              </a:rPr>
+              <a:t>Handout: docs/talk/handout.md (copy-paste prompts + action plan) · Contact: eranti@gmail.com</a:t>
+            </a:r>
+          </a:p>
+        </p:txBody>
+      </p:sp>
+      <p:sp>
+        <p:nvSpPr>
+          <p:cNvPr id="5" name="TextBox 4"/>
+          <p:cNvSpPr txBox="1"/>
+          <p:nvPr/>
+        </p:nvSpPr>
+        <p:spPr>
+          <a:xfrm>
+            <a:off x="640080" y="5349240"/>
+            <a:ext cx="10908792" cy="640080"/>
+          </a:xfrm>
+          <a:prstGeom prst="rect">
+            <a:avLst/>
+          </a:prstGeom>
+          <a:noFill/>
+        </p:spPr>
+        <p:txBody>
+          <a:bodyPr wrap="square">
+            <a:spAutoFit/>
+          </a:bodyPr>
+          <a:lstStyle/>
+          <a:p>
+            <a:r>
+              <a:rPr sz="1100" b="0" i="1">
+                <a:solidFill>
+                  <a:srgbClr val="9AA0A6"/>
+                </a:solidFill>
+                <a:latin typeface="Calibri"/>
+              </a:rPr>
+              <a:t>[Visual placeholder] A clean resource card with the arXiv IDs and dataset names, a QR placeholder to the public repo, and contact info.</a:t>
+            </a:r>
+          </a:p>
+        </p:txBody>
+      </p:sp>
+      <p:sp>
+        <p:nvSpPr>
+          <p:cNvPr id="6" name="TextBox 5"/>
+          <p:cNvSpPr txBox="1"/>
+          <p:nvPr/>
+        </p:nvSpPr>
+        <p:spPr>
+          <a:xfrm>
+            <a:off x="640080" y="5989320"/>
+            <a:ext cx="10908792" cy="640080"/>
+          </a:xfrm>
+          <a:prstGeom prst="rect">
+            <a:avLst/>
+          </a:prstGeom>
+          <a:noFill/>
+        </p:spPr>
+        <p:txBody>
+          <a:bodyPr wrap="square" anchor="ctr">
+            <a:spAutoFit/>
+          </a:bodyPr>
+          <a:lstStyle/>
+          <a:p>
+            <a:r>
+              <a:rPr sz="1600" b="1" i="0">
+                <a:solidFill>
+                  <a:srgbClr val="188038"/>
+                </a:solidFill>
+                <a:latin typeface="Calibri"/>
+              </a:rPr>
+              <a:t>TAKEAWAY: Take the handout, clone the repo, and try one prompt tonight.</a:t>
+            </a:r>
+          </a:p>
+        </p:txBody>
+      </p:sp>
+    </p:spTree>
+  </p:cSld>
+  <p:clrMapOvr>
+    <a:masterClrMapping/>
+  </p:clrMapOvr>
+</p:sld>
+</file>
+
 <file path=ppt/slides/slide3.xml><?xml version="1.0" encoding="utf-8"?>
 <p:sld xmlns:a="http://schemas.openxmlformats.org/drawingml/2006/main" xmlns:p="http://schemas.openxmlformats.org/presentationml/2006/main" xmlns:r="http://schemas.openxmlformats.org/officeDocument/2006/relationships">
   <p:cSld>
@@ -9558,16 +10562,64 @@
           </a:p>
         </p:txBody>
       </p:sp>
-      <p:sp>
-        <p:nvSpPr>
-          <p:cNvPr id="4" name="TextBox 3"/>
+      <p:pic>
+        <p:nvPicPr>
+          <p:cNvPr id="4" name="Picture 3" descr="forecast_plot.png"/>
+          <p:cNvPicPr>
+            <a:picLocks noChangeAspect="1"/>
+          </p:cNvPicPr>
+          <p:nvPr/>
+        </p:nvPicPr>
+        <p:blipFill>
+          <a:blip r:embed="rId2"/>
+          <a:stretch>
+            <a:fillRect/>
+          </a:stretch>
+        </p:blipFill>
+        <p:spPr>
+          <a:xfrm>
+            <a:off x="6674060" y="1417320"/>
+            <a:ext cx="4574119" cy="2112264"/>
+          </a:xfrm>
+          <a:prstGeom prst="rect">
+            <a:avLst/>
+          </a:prstGeom>
+        </p:spPr>
+      </p:pic>
+      <p:pic>
+        <p:nvPicPr>
+          <p:cNvPr id="5" name="Picture 4" descr="before_after_bars.png"/>
+          <p:cNvPicPr>
+            <a:picLocks noChangeAspect="1"/>
+          </p:cNvPicPr>
+          <p:nvPr/>
+        </p:nvPicPr>
+        <p:blipFill>
+          <a:blip r:embed="rId3"/>
+          <a:stretch>
+            <a:fillRect/>
+          </a:stretch>
+        </p:blipFill>
+        <p:spPr>
+          <a:xfrm>
+            <a:off x="7440511" y="3694176"/>
+            <a:ext cx="3041218" cy="2112264"/>
+          </a:xfrm>
+          <a:prstGeom prst="rect">
+            <a:avLst/>
+          </a:prstGeom>
+        </p:spPr>
+      </p:pic>
+      <p:sp>
+        <p:nvSpPr>
+          <p:cNvPr id="6" name="TextBox 5"/>
           <p:cNvSpPr txBox="1"/>
           <p:nvPr/>
         </p:nvSpPr>
         <p:spPr>
           <a:xfrm>
             <a:off x="640080" y="1371600"/>
-            <a:ext cx="10908792" cy="3840480"/>
+            <a:ext cx="5440680" cy="3840480"/>
           </a:xfrm>
           <a:prstGeom prst="rect">
             <a:avLst/>
@@ -9589,7 +10641,7 @@
               </a:spcAft>
             </a:pPr>
             <a:r>
-              <a:rPr sz="1800" b="1" i="0">
+              <a:rPr sz="1600" b="1" i="0">
                 <a:solidFill>
                   <a:srgbClr val="188038"/>
                 </a:solidFill>
@@ -9598,7 +10650,7 @@
               <a:t>•  </a:t>
             </a:r>
             <a:r>
-              <a:rPr sz="1800" b="0" i="0">
+              <a:rPr sz="1600" b="0" i="0">
                 <a:solidFill>
                   <a:srgbClr val="333333"/>
                 </a:solidFill>
@@ -9617,7 +10669,7 @@
               </a:spcAft>
             </a:pPr>
             <a:r>
-              <a:rPr sz="1800" b="1" i="0">
+              <a:rPr sz="1600" b="1" i="0">
                 <a:solidFill>
                   <a:srgbClr val="188038"/>
                 </a:solidFill>
@@ -9626,7 +10678,7 @@
               <a:t>•  </a:t>
             </a:r>
             <a:r>
-              <a:rPr sz="1800" b="0" i="0">
+              <a:rPr sz="1600" b="0" i="0">
                 <a:solidFill>
                   <a:srgbClr val="333333"/>
                 </a:solidFill>
@@ -9645,7 +10697,7 @@
               </a:spcAft>
             </a:pPr>
             <a:r>
-              <a:rPr sz="1800" b="1" i="0">
+              <a:rPr sz="1600" b="1" i="0">
                 <a:solidFill>
                   <a:srgbClr val="188038"/>
                 </a:solidFill>
@@ -9654,7 +10706,7 @@
               <a:t>•  </a:t>
             </a:r>
             <a:r>
-              <a:rPr sz="1800" b="0" i="0">
+              <a:rPr sz="1600" b="0" i="0">
                 <a:solidFill>
                   <a:srgbClr val="333333"/>
                 </a:solidFill>
@@ -9673,7 +10725,7 @@
               </a:spcAft>
             </a:pPr>
             <a:r>
-              <a:rPr sz="1800" b="1" i="0">
+              <a:rPr sz="1600" b="1" i="0">
                 <a:solidFill>
                   <a:srgbClr val="188038"/>
                 </a:solidFill>
@@ -9682,7 +10734,7 @@
               <a:t>•  </a:t>
             </a:r>
             <a:r>
-              <a:rPr sz="1800" b="0" i="0">
+              <a:rPr sz="1600" b="0" i="0">
                 <a:solidFill>
                   <a:srgbClr val="333333"/>
                 </a:solidFill>
@@ -9701,7 +10753,7 @@
               </a:spcAft>
             </a:pPr>
             <a:r>
-              <a:rPr sz="1800" b="1" i="0">
+              <a:rPr sz="1600" b="1" i="0">
                 <a:solidFill>
                   <a:srgbClr val="188038"/>
                 </a:solidFill>
@@ -9710,7 +10762,7 @@
               <a:t>•  </a:t>
             </a:r>
             <a:r>
-              <a:rPr sz="1800" b="0" i="0">
+              <a:rPr sz="1600" b="0" i="0">
                 <a:solidFill>
                   <a:srgbClr val="333333"/>
                 </a:solidFill>
@@ -9723,14 +10775,14 @@
       </p:sp>
       <p:sp>
         <p:nvSpPr>
-          <p:cNvPr id="5" name="TextBox 4"/>
+          <p:cNvPr id="7" name="TextBox 6"/>
           <p:cNvSpPr txBox="1"/>
           <p:nvPr/>
         </p:nvSpPr>
         <p:spPr>
           <a:xfrm>
-            <a:off x="640080" y="5349240"/>
-            <a:ext cx="10908792" cy="640080"/>
+            <a:off x="640080" y="5440680"/>
+            <a:ext cx="5440680" cy="548640"/>
           </a:xfrm>
           <a:prstGeom prst="rect">
             <a:avLst/>
@@ -9744,20 +10796,20 @@
           <a:lstStyle/>
           <a:p>
             <a:r>
-              <a:rPr sz="1100" b="0" i="1">
+              <a:rPr sz="1000" b="0" i="1">
                 <a:solidFill>
                   <a:srgbClr val="9AA0A6"/>
                 </a:solidFill>
                 <a:latin typeface="Calibri"/>
               </a:rPr>
-              <a:t>[Visual placeholder] Live terminal, then the generated forecast plot + a BEFORE/AFTER RMSE bar (the repo's before_after_bars helper). Recorded-backup screenshot on the slide as fallback.</a:t>
-            </a:r>
-          </a:p>
-        </p:txBody>
-      </p:sp>
-      <p:sp>
-        <p:nvSpPr>
-          <p:cNvPr id="6" name="TextBox 5"/>
+              <a:t>[Figure: committed result] Live terminal, then the generated forecast plot + a BEFORE/AFTER RMSE bar (the repo's before_after_bars helper). Recorded-backup screenshot on the slide as fallback.</a:t>
+            </a:r>
+          </a:p>
+        </p:txBody>
+      </p:sp>
+      <p:sp>
+        <p:nvSpPr>
+          <p:cNvPr id="8" name="TextBox 7"/>
           <p:cNvSpPr txBox="1"/>
           <p:nvPr/>
         </p:nvSpPr>
@@ -9893,16 +10945,64 @@
           </a:p>
         </p:txBody>
       </p:sp>
-      <p:sp>
-        <p:nvSpPr>
-          <p:cNvPr id="4" name="TextBox 3"/>
+      <p:pic>
+        <p:nvPicPr>
+          <p:cNvPr id="4" name="Picture 3" descr="return_levels.png"/>
+          <p:cNvPicPr>
+            <a:picLocks noChangeAspect="1"/>
+          </p:cNvPicPr>
+          <p:nvPr/>
+        </p:nvPicPr>
+        <p:blipFill>
+          <a:blip r:embed="rId2"/>
+          <a:stretch>
+            <a:fillRect/>
+          </a:stretch>
+        </p:blipFill>
+        <p:spPr>
+          <a:xfrm>
+            <a:off x="7217274" y="1417320"/>
+            <a:ext cx="3487692" cy="2112264"/>
+          </a:xfrm>
+          <a:prstGeom prst="rect">
+            <a:avLst/>
+          </a:prstGeom>
+        </p:spPr>
+      </p:pic>
+      <p:pic>
+        <p:nvPicPr>
+          <p:cNvPr id="5" name="Picture 4" descr="trend_plot.png"/>
+          <p:cNvPicPr>
+            <a:picLocks noChangeAspect="1"/>
+          </p:cNvPicPr>
+          <p:nvPr/>
+        </p:nvPicPr>
+        <p:blipFill>
+          <a:blip r:embed="rId3"/>
+          <a:stretch>
+            <a:fillRect/>
+          </a:stretch>
+        </p:blipFill>
+        <p:spPr>
+          <a:xfrm>
+            <a:off x="7222537" y="3694176"/>
+            <a:ext cx="3477165" cy="2112264"/>
+          </a:xfrm>
+          <a:prstGeom prst="rect">
+            <a:avLst/>
+          </a:prstGeom>
+        </p:spPr>
+      </p:pic>
+      <p:sp>
+        <p:nvSpPr>
+          <p:cNvPr id="6" name="TextBox 5"/>
           <p:cNvSpPr txBox="1"/>
           <p:nvPr/>
         </p:nvSpPr>
         <p:spPr>
           <a:xfrm>
             <a:off x="640080" y="1371600"/>
-            <a:ext cx="10908792" cy="3840480"/>
+            <a:ext cx="5440680" cy="3840480"/>
           </a:xfrm>
           <a:prstGeom prst="rect">
             <a:avLst/>
@@ -9924,7 +11024,7 @@
               </a:spcAft>
             </a:pPr>
             <a:r>
-              <a:rPr sz="1800" b="1" i="0">
+              <a:rPr sz="1600" b="1" i="0">
                 <a:solidFill>
                   <a:srgbClr val="188038"/>
                 </a:solidFill>
@@ -9933,7 +11033,7 @@
               <a:t>•  </a:t>
             </a:r>
             <a:r>
-              <a:rPr sz="1800" b="0" i="0">
+              <a:rPr sz="1600" b="0" i="0">
                 <a:solidFill>
                   <a:srgbClr val="333333"/>
                 </a:solidFill>
@@ -9952,7 +11052,7 @@
               </a:spcAft>
             </a:pPr>
             <a:r>
-              <a:rPr sz="1800" b="1" i="0">
+              <a:rPr sz="1600" b="1" i="0">
                 <a:solidFill>
                   <a:srgbClr val="188038"/>
                 </a:solidFill>
@@ -9961,7 +11061,7 @@
               <a:t>•  </a:t>
             </a:r>
             <a:r>
-              <a:rPr sz="1800" b="0" i="0">
+              <a:rPr sz="1600" b="0" i="0">
                 <a:solidFill>
                   <a:srgbClr val="333333"/>
                 </a:solidFill>
@@ -9980,7 +11080,7 @@
               </a:spcAft>
             </a:pPr>
             <a:r>
-              <a:rPr sz="1800" b="1" i="0">
+              <a:rPr sz="1600" b="1" i="0">
                 <a:solidFill>
                   <a:srgbClr val="188038"/>
                 </a:solidFill>
@@ -9989,7 +11089,7 @@
               <a:t>•  </a:t>
             </a:r>
             <a:r>
-              <a:rPr sz="1800" b="0" i="0">
+              <a:rPr sz="1600" b="0" i="0">
                 <a:solidFill>
                   <a:srgbClr val="333333"/>
                 </a:solidFill>
@@ -10008,7 +11108,7 @@
               </a:spcAft>
             </a:pPr>
             <a:r>
-              <a:rPr sz="1800" b="1" i="0">
+              <a:rPr sz="1600" b="1" i="0">
                 <a:solidFill>
                   <a:srgbClr val="188038"/>
                 </a:solidFill>
@@ -10017,7 +11117,7 @@
               <a:t>•  </a:t>
             </a:r>
             <a:r>
-              <a:rPr sz="1800" b="0" i="0">
+              <a:rPr sz="1600" b="0" i="0">
                 <a:solidFill>
                   <a:srgbClr val="333333"/>
                 </a:solidFill>
@@ -10036,7 +11136,7 @@
               </a:spcAft>
             </a:pPr>
             <a:r>
-              <a:rPr sz="1800" b="1" i="0">
+              <a:rPr sz="1600" b="1" i="0">
                 <a:solidFill>
                   <a:srgbClr val="188038"/>
                 </a:solidFill>
@@ -10045,7 +11145,7 @@
               <a:t>•  </a:t>
             </a:r>
             <a:r>
-              <a:rPr sz="1800" b="0" i="0">
+              <a:rPr sz="1600" b="0" i="0">
                 <a:solidFill>
                   <a:srgbClr val="333333"/>
                 </a:solidFill>
@@ -10058,14 +11158,14 @@
       </p:sp>
       <p:sp>
         <p:nvSpPr>
-          <p:cNvPr id="5" name="TextBox 4"/>
+          <p:cNvPr id="7" name="TextBox 6"/>
           <p:cNvSpPr txBox="1"/>
           <p:nvPr/>
         </p:nvSpPr>
         <p:spPr>
           <a:xfrm>
-            <a:off x="640080" y="5349240"/>
-            <a:ext cx="10908792" cy="640080"/>
+            <a:off x="640080" y="5440680"/>
+            <a:ext cx="5440680" cy="548640"/>
           </a:xfrm>
           <a:prstGeom prst="rect">
             <a:avLst/>
@@ -10079,20 +11179,20 @@
           <a:lstStyle/>
           <a:p>
             <a:r>
-              <a:rPr sz="1100" b="0" i="1">
+              <a:rPr sz="1000" b="0" i="1">
                 <a:solidFill>
                   <a:srgbClr val="9AA0A6"/>
                 </a:solidFill>
                 <a:latin typeface="Calibri"/>
               </a:rPr>
-              <a:t>[Visual placeholder] Return-level curve with confidence band + a trend slope with its CI; small inset of the auto-generated rigor checklist.</a:t>
-            </a:r>
-          </a:p>
-        </p:txBody>
-      </p:sp>
-      <p:sp>
-        <p:nvSpPr>
-          <p:cNvPr id="6" name="TextBox 5"/>
+              <a:t>[Figure: committed result] Return-level curve with confidence band + a trend slope with its CI; small inset of the auto-generated rigor checklist.</a:t>
+            </a:r>
+          </a:p>
+        </p:txBody>
+      </p:sp>
+      <p:sp>
+        <p:nvSpPr>
+          <p:cNvPr id="8" name="TextBox 7"/>
           <p:cNvSpPr txBox="1"/>
           <p:nvPr/>
         </p:nvSpPr>

</xml_diff>

<commit_message>
deck: add Exp09 (Bayesian amortized) + Exp10 (SDM) slides — 22 slides, full parity
Two new demo slides between conformal UQ and the flagship divider, with embedded
posterior_intervals.png + suitability_map.png. Real numbers only. Theme/notes intact.

Co-Authored-By: Claude Opus 4.7 (1M context) <noreply@anthropic.com>
</commit_message>
<xml_diff>
--- a/docs/talk/deck.pptx
+++ b/docs/talk/deck.pptx
@@ -25,6 +25,8 @@
     <p:sldId id="273" r:id="rId25"/>
     <p:sldId id="274" r:id="rId26"/>
     <p:sldId id="275" r:id="rId27"/>
+    <p:sldId id="276" r:id="rId28"/>
+    <p:sldId id="277" r:id="rId29"/>
   </p:sldIdLst>
   <p:sldSz cx="12191695" cy="6858000" type="screen4x3"/>
   <p:notesSz cx="6858000" cy="9144000"/>
@@ -871,7 +873,7 @@
           <a:lstStyle/>
           <a:p>
             <a:r>
-              <a:t>Now the flagship: an autonomous, gated research loop running unattended on a single 4090.</a:t>
+              <a:t>Bayesian hierarchical inference is the cell where amortization changes the economics. BEFORE we re-ran an honest Metropolis-Hastings sampler for every new dataset — about 11.6 seconds each, fine for one, painful for thousands. AFTER, a small MLP trained once over simulations scores a new dataset in 0.008 seconds, roughly 1451× faster, and the 24.5-second training cost pays back by the second dataset. Coverage matches at the nominal 95%, and I'm explicit that the amortized intervals are wider — you're trading a little sharpness for enormous speed.</a:t>
             </a:r>
           </a:p>
         </p:txBody>
@@ -941,7 +943,7 @@
           <a:lstStyle/>
           <a:p>
             <a:r>
-              <a:t>This is the part that feels like science fiction but isn't. The autoresearch loop turns Claude Code into the researcher: it diagnoses the current best model, cites prior work, forms a hypothesis, predicts the outcome, runs exactly one experiment, analyzes it, and checkpoints. Two gates matter for this audience — it cannot run an experiment until its citations and its reasoning pass a completeness check, which is the machine-enforced version of "don't fish." It produces a champion archive and a human-readable journal you can audit afterward.</a:t>
+              <a:t>Species distribution modeling is a cell where AFTER wins cleanly on every metric — modestly on AUC (+0.023) and Brier (−0.002), but dramatically on true-suitability correlation (+0.188). That last number is the one that matters scientifically: the gradient boosting model recovers the elevation by climate interaction that defines the niche, which a logistic GLM with squared terms structurally can't encode. I keep the GLM as the safer choice for extrapolation, because nothing about boosting saves you outside the training envelope.</a:t>
             </a:r>
           </a:p>
         </p:txBody>
@@ -1011,7 +1013,7 @@
           <a:lstStyle/>
           <a:p>
             <a:r>
-              <a:t>Let me be careful here, because over-claiming would lose this room. The loop is excellent at exhaustively and transparently searching a space you define and archiving what wins. It does not pick the question, the loss function, or the standard of validity — that is your job, and the system is designed to keep it your job, including a fingerprint that flags if the objective quietly drifts mid-run. Treat its output as a well-documented draft to review, never as an oracle.</a:t>
+              <a:t>Now the flagship: an autonomous, gated research loop running unattended on a single 4090.</a:t>
             </a:r>
           </a:p>
         </p:txBody>
@@ -1081,7 +1083,7 @@
           <a:lstStyle/>
           <a:p>
             <a:r>
-              <a:t>Here are the failure modes I worry about, and how this setup defends against each. Leakage is the big one, so splits are chronological or spatial by construction. Multiplicity is corrected explicitly when we scan many units. Uncertainty is reported as intervals, never bare point estimates. And because LLMs can fabricate references, anything not independently verified is quarantined and never stated as fact — that discipline is why I keep saying "see RESULTS.md" instead of quoting numbers from memory.</a:t>
+              <a:t>This is the part that feels like science fiction but isn't. The autoresearch loop turns Claude Code into the researcher: it diagnoses the current best model, cites prior work, forms a hypothesis, predicts the outcome, runs exactly one experiment, analyzes it, and checkpoints. Two gates matter for this audience — it cannot run an experiment until its citations and its reasoning pass a completeness check, which is the machine-enforced version of "don't fish." It produces a champion archive and a human-readable journal you can audit afterward.</a:t>
             </a:r>
           </a:p>
         </p:txBody>
@@ -1151,7 +1153,7 @@
           <a:lstStyle/>
           <a:p>
             <a:r>
-              <a:t>Concrete next steps, because I want you to leave with momentum. Today, just install the agent and ask it to redraw one figure from your most recent paper — low stakes, instant intuition. This week, give it a whole small pipeline end to end. This month, encode your group's validation rules as a reusable skill so the agent inherits your standards. Start on synthetic or small public data so nothing blocks you, then scale to real data and the GPU.</a:t>
+              <a:t>Let me be careful here, because over-claiming would lose this room. The loop is excellent at exhaustively and transparently searching a space you define and archiving what wins. It does not pick the question, the loss function, or the standard of validity — that is your job, and the system is designed to keep it your job, including a fingerprint that flags if the objective quietly drifts mid-run. Treat its output as a well-documented draft to review, never as an oracle.</a:t>
             </a:r>
           </a:p>
         </p:txBody>
@@ -1221,7 +1223,7 @@
           <a:lstStyle/>
           <a:p>
             <a:r>
-              <a:t>Zoom out. If labor stops being the constraint, then judgment becomes the differentiator — and judgment is what statistical training produces. I think the near future is each of us orchestrating a handful of agents across the taxonomy, with better audit trails than we have today because everything is logged and reproducible. The role doesn't shrink; it moves up the stack to the parts that were always the science.</a:t>
+              <a:t>Here are the failure modes I worry about, and how this setup defends against each. Leakage is the big one, so splits are chronological or spatial by construction. Multiplicity is corrected explicitly when we scan many units. Uncertainty is reported as intervals, never bare point estimates. And because LLMs can fabricate references, anything not independently verified is quarantined and never stated as fact — that discipline is why I keep saying "see RESULTS.md" instead of quoting numbers from memory.</a:t>
             </a:r>
           </a:p>
         </p:txBody>
@@ -1317,6 +1319,146 @@
 </file>
 
 <file path=ppt/notesSlides/notesSlide20.xml><?xml version="1.0" encoding="utf-8"?>
+<p:notes xmlns:a="http://schemas.openxmlformats.org/drawingml/2006/main" xmlns:p="http://schemas.openxmlformats.org/presentationml/2006/main" xmlns:r="http://schemas.openxmlformats.org/officeDocument/2006/relationships">
+  <p:cSld>
+    <p:spTree>
+      <p:nvGrpSpPr>
+        <p:cNvPr id="1" name=""/>
+        <p:cNvGrpSpPr/>
+        <p:nvPr/>
+      </p:nvGrpSpPr>
+      <p:grpSpPr>
+        <a:xfrm>
+          <a:off x="0" y="0"/>
+          <a:ext cx="0" cy="0"/>
+          <a:chOff x="0" y="0"/>
+          <a:chExt cx="0" cy="0"/>
+        </a:xfrm>
+      </p:grpSpPr>
+      <p:sp>
+        <p:nvSpPr>
+          <p:cNvPr id="2" name="Slide Image Placeholder 1"/>
+          <p:cNvSpPr>
+            <a:spLocks noGrp="1"/>
+          </p:cNvSpPr>
+          <p:nvPr>
+            <p:ph type="sldImg" idx="2"/>
+          </p:nvPr>
+        </p:nvSpPr>
+        <p:spPr/>
+      </p:sp>
+      <p:sp>
+        <p:nvSpPr>
+          <p:cNvPr id="3" name="Notes Placeholder 2"/>
+          <p:cNvSpPr>
+            <a:spLocks noGrp="1"/>
+          </p:cNvSpPr>
+          <p:nvPr>
+            <p:ph type="body" idx="3" sz="quarter"/>
+          </p:nvPr>
+        </p:nvSpPr>
+        <p:spPr/>
+        <p:txBody>
+          <a:bodyPr/>
+          <a:lstStyle/>
+          <a:p>
+            <a:r>
+              <a:t>Concrete next steps, because I want you to leave with momentum. Today, just install the agent and ask it to redraw one figure from your most recent paper — low stakes, instant intuition. This week, give it a whole small pipeline end to end. This month, encode your group's validation rules as a reusable skill so the agent inherits your standards. Start on synthetic or small public data so nothing blocks you, then scale to real data and the GPU.</a:t>
+            </a:r>
+          </a:p>
+        </p:txBody>
+      </p:sp>
+      <p:sp>
+        <p:nvSpPr>
+          <p:cNvPr id="4" name="Slide Number Placeholder 3"/>
+          <p:cNvSpPr>
+            <a:spLocks noGrp="1"/>
+          </p:cNvSpPr>
+          <p:nvPr>
+            <p:ph type="sldNum" idx="5" sz="quarter"/>
+          </p:nvPr>
+        </p:nvSpPr>
+        <p:spPr/>
+      </p:sp>
+    </p:spTree>
+  </p:cSld>
+  <p:clrMapOvr>
+    <a:masterClrMapping/>
+  </p:clrMapOvr>
+</p:notes>
+</file>
+
+<file path=ppt/notesSlides/notesSlide21.xml><?xml version="1.0" encoding="utf-8"?>
+<p:notes xmlns:a="http://schemas.openxmlformats.org/drawingml/2006/main" xmlns:p="http://schemas.openxmlformats.org/presentationml/2006/main" xmlns:r="http://schemas.openxmlformats.org/officeDocument/2006/relationships">
+  <p:cSld>
+    <p:spTree>
+      <p:nvGrpSpPr>
+        <p:cNvPr id="1" name=""/>
+        <p:cNvGrpSpPr/>
+        <p:nvPr/>
+      </p:nvGrpSpPr>
+      <p:grpSpPr>
+        <a:xfrm>
+          <a:off x="0" y="0"/>
+          <a:ext cx="0" cy="0"/>
+          <a:chOff x="0" y="0"/>
+          <a:chExt cx="0" cy="0"/>
+        </a:xfrm>
+      </p:grpSpPr>
+      <p:sp>
+        <p:nvSpPr>
+          <p:cNvPr id="2" name="Slide Image Placeholder 1"/>
+          <p:cNvSpPr>
+            <a:spLocks noGrp="1"/>
+          </p:cNvSpPr>
+          <p:nvPr>
+            <p:ph type="sldImg" idx="2"/>
+          </p:nvPr>
+        </p:nvSpPr>
+        <p:spPr/>
+      </p:sp>
+      <p:sp>
+        <p:nvSpPr>
+          <p:cNvPr id="3" name="Notes Placeholder 2"/>
+          <p:cNvSpPr>
+            <a:spLocks noGrp="1"/>
+          </p:cNvSpPr>
+          <p:nvPr>
+            <p:ph type="body" idx="3" sz="quarter"/>
+          </p:nvPr>
+        </p:nvSpPr>
+        <p:spPr/>
+        <p:txBody>
+          <a:bodyPr/>
+          <a:lstStyle/>
+          <a:p>
+            <a:r>
+              <a:t>Zoom out. If labor stops being the constraint, then judgment becomes the differentiator — and judgment is what statistical training produces. I think the near future is each of us orchestrating a handful of agents across the taxonomy, with better audit trails than we have today because everything is logged and reproducible. The role doesn't shrink; it moves up the stack to the parts that were always the science.</a:t>
+            </a:r>
+          </a:p>
+        </p:txBody>
+      </p:sp>
+      <p:sp>
+        <p:nvSpPr>
+          <p:cNvPr id="4" name="Slide Number Placeholder 3"/>
+          <p:cNvSpPr>
+            <a:spLocks noGrp="1"/>
+          </p:cNvSpPr>
+          <p:nvPr>
+            <p:ph type="sldNum" idx="5" sz="quarter"/>
+          </p:nvPr>
+        </p:nvSpPr>
+        <p:spPr/>
+      </p:sp>
+    </p:spTree>
+  </p:cSld>
+  <p:clrMapOvr>
+    <a:masterClrMapping/>
+  </p:clrMapOvr>
+</p:notes>
+</file>
+
+<file path=ppt/notesSlides/notesSlide22.xml><?xml version="1.0" encoding="utf-8"?>
 <p:notes xmlns:a="http://schemas.openxmlformats.org/drawingml/2006/main" xmlns:p="http://schemas.openxmlformats.org/presentationml/2006/main" xmlns:r="http://schemas.openxmlformats.org/officeDocument/2006/relationships">
   <p:cSld>
     <p:spTree>
@@ -6611,7 +6753,7 @@
     <p:bg>
       <p:bgPr>
         <a:solidFill>
-          <a:srgbClr val="1A3A5C"/>
+          <a:srgbClr val="FFFFFF"/>
         </a:solidFill>
         <a:effectLst/>
       </p:bgPr>
@@ -6625,14 +6767,58 @@
       <p:grpSpPr/>
       <p:sp>
         <p:nvSpPr>
-          <p:cNvPr id="2" name="TextBox 1"/>
+          <p:cNvPr id="2" name="Rectangle 1"/>
+          <p:cNvSpPr/>
+          <p:nvPr/>
+        </p:nvSpPr>
+        <p:spPr>
+          <a:xfrm>
+            <a:off x="0" y="0"/>
+            <a:ext cx="12191695" cy="146304"/>
+          </a:xfrm>
+          <a:prstGeom prst="rect">
+            <a:avLst/>
+          </a:prstGeom>
+          <a:solidFill>
+            <a:srgbClr val="1A3A5C"/>
+          </a:solidFill>
+          <a:ln>
+            <a:noFill/>
+          </a:ln>
+          <a:effectLst/>
+        </p:spPr>
+        <p:style>
+          <a:lnRef idx="1">
+            <a:schemeClr val="accent1"/>
+          </a:lnRef>
+          <a:fillRef idx="3">
+            <a:schemeClr val="accent1"/>
+          </a:fillRef>
+          <a:effectRef idx="2">
+            <a:schemeClr val="accent1"/>
+          </a:effectRef>
+          <a:fontRef idx="minor">
+            <a:schemeClr val="lt1"/>
+          </a:fontRef>
+        </p:style>
+        <p:txBody>
+          <a:bodyPr rtlCol="0" anchor="ctr"/>
+          <a:lstStyle/>
+          <a:p>
+            <a:pPr algn="ctr"/>
+          </a:p>
+        </p:txBody>
+      </p:sp>
+      <p:sp>
+        <p:nvSpPr>
+          <p:cNvPr id="3" name="TextBox 2"/>
           <p:cNvSpPr txBox="1"/>
           <p:nvPr/>
         </p:nvSpPr>
         <p:spPr>
           <a:xfrm>
-            <a:off x="822960" y="2468880"/>
-            <a:ext cx="10515600" cy="1828800"/>
+            <a:off x="640080" y="292608"/>
+            <a:ext cx="10908792" cy="914400"/>
           </a:xfrm>
           <a:prstGeom prst="rect">
             <a:avLst/>
@@ -6646,29 +6832,292 @@
           <a:lstStyle/>
           <a:p>
             <a:r>
-              <a:rPr sz="1800" b="1" i="0">
-                <a:solidFill>
-                  <a:srgbClr val="BFD8C2"/>
-                </a:solidFill>
-                <a:latin typeface="Calibri"/>
-              </a:rPr>
-              <a:t>THE FLAGSHIP</a:t>
-            </a:r>
-          </a:p>
+              <a:rPr sz="2800" b="1" i="0">
+                <a:solidFill>
+                  <a:srgbClr val="1A3A5C"/>
+                </a:solidFill>
+                <a:latin typeface="Calibri"/>
+              </a:rPr>
+              <a:t>Bonus demo: Bayesian hierarchical — MCMC vs amortized — Exp09</a:t>
+            </a:r>
+          </a:p>
+        </p:txBody>
+      </p:sp>
+      <p:pic>
+        <p:nvPicPr>
+          <p:cNvPr id="4" name="Picture 3" descr="posterior_intervals.png"/>
+          <p:cNvPicPr>
+            <a:picLocks noChangeAspect="1"/>
+          </p:cNvPicPr>
+          <p:nvPr/>
+        </p:nvPicPr>
+        <p:blipFill>
+          <a:blip r:embed="rId2"/>
+          <a:stretch>
+            <a:fillRect/>
+          </a:stretch>
+        </p:blipFill>
+        <p:spPr>
+          <a:xfrm>
+            <a:off x="6624470" y="1417320"/>
+            <a:ext cx="4673300" cy="2112264"/>
+          </a:xfrm>
+          <a:prstGeom prst="rect">
+            <a:avLst/>
+          </a:prstGeom>
+        </p:spPr>
+      </p:pic>
+      <p:pic>
+        <p:nvPicPr>
+          <p:cNvPr id="5" name="Picture 4" descr="before_after_bars.png"/>
+          <p:cNvPicPr>
+            <a:picLocks noChangeAspect="1"/>
+          </p:cNvPicPr>
+          <p:nvPr/>
+        </p:nvPicPr>
+        <p:blipFill>
+          <a:blip r:embed="rId3"/>
+          <a:stretch>
+            <a:fillRect/>
+          </a:stretch>
+        </p:blipFill>
+        <p:spPr>
+          <a:xfrm>
+            <a:off x="6446520" y="3758993"/>
+            <a:ext cx="5029200" cy="1982630"/>
+          </a:xfrm>
+          <a:prstGeom prst="rect">
+            <a:avLst/>
+          </a:prstGeom>
+        </p:spPr>
+      </p:pic>
+      <p:sp>
+        <p:nvSpPr>
+          <p:cNvPr id="6" name="TextBox 5"/>
+          <p:cNvSpPr txBox="1"/>
+          <p:nvPr/>
+        </p:nvSpPr>
+        <p:spPr>
+          <a:xfrm>
+            <a:off x="640080" y="1371600"/>
+            <a:ext cx="5440680" cy="3840480"/>
+          </a:xfrm>
+          <a:prstGeom prst="rect">
+            <a:avLst/>
+          </a:prstGeom>
+          <a:noFill/>
+        </p:spPr>
+        <p:txBody>
+          <a:bodyPr wrap="square">
+            <a:spAutoFit/>
+          </a:bodyPr>
+          <a:lstStyle/>
           <a:p>
             <a:pPr>
-              <a:spcBef>
-                <a:spcPts val="800"/>
-              </a:spcBef>
+              <a:lnSpc>
+                <a:spcPct val="110000"/>
+              </a:lnSpc>
+              <a:spcAft>
+                <a:spcPts val="1200"/>
+              </a:spcAft>
             </a:pPr>
             <a:r>
-              <a:rPr sz="3400" b="1" i="0">
-                <a:solidFill>
-                  <a:srgbClr val="FFFFFF"/>
-                </a:solidFill>
-                <a:latin typeface="Calibri"/>
-              </a:rPr>
-              <a:t>An autonomous research loop — Exp05</a:t>
+              <a:rPr sz="1600" b="1" i="0">
+                <a:solidFill>
+                  <a:srgbClr val="188038"/>
+                </a:solidFill>
+                <a:latin typeface="Calibri"/>
+              </a:rPr>
+              <a:t>•  </a:t>
+            </a:r>
+            <a:r>
+              <a:rPr sz="1600" b="0" i="0">
+                <a:solidFill>
+                  <a:srgbClr val="333333"/>
+                </a:solidFill>
+                <a:latin typeface="Calibri"/>
+              </a:rPr>
+              <a:t>Task: posterior inference for a partial-pooling hierarchical model on many datasets</a:t>
+            </a:r>
+          </a:p>
+          <a:p>
+            <a:pPr>
+              <a:lnSpc>
+                <a:spcPct val="110000"/>
+              </a:lnSpc>
+              <a:spcAft>
+                <a:spcPts val="1200"/>
+              </a:spcAft>
+            </a:pPr>
+            <a:r>
+              <a:rPr sz="1600" b="1" i="0">
+                <a:solidFill>
+                  <a:srgbClr val="188038"/>
+                </a:solidFill>
+                <a:latin typeface="Calibri"/>
+              </a:rPr>
+              <a:t>•  </a:t>
+            </a:r>
+            <a:r>
+              <a:rPr sz="1600" b="0" i="0">
+                <a:solidFill>
+                  <a:srgbClr val="333333"/>
+                </a:solidFill>
+                <a:latin typeface="Calibri"/>
+              </a:rPr>
+              <a:t>BEFORE: from-scratch Metropolis-Hastings — 11.6 s per new dataset (re-run every time)</a:t>
+            </a:r>
+          </a:p>
+          <a:p>
+            <a:pPr>
+              <a:lnSpc>
+                <a:spcPct val="110000"/>
+              </a:lnSpc>
+              <a:spcAft>
+                <a:spcPts val="1200"/>
+              </a:spcAft>
+            </a:pPr>
+            <a:r>
+              <a:rPr sz="1600" b="1" i="0">
+                <a:solidFill>
+                  <a:srgbClr val="188038"/>
+                </a:solidFill>
+                <a:latin typeface="Calibri"/>
+              </a:rPr>
+              <a:t>•  </a:t>
+            </a:r>
+            <a:r>
+              <a:rPr sz="1600" b="0" i="0">
+                <a:solidFill>
+                  <a:srgbClr val="333333"/>
+                </a:solidFill>
+                <a:latin typeface="Calibri"/>
+              </a:rPr>
+              <a:t>AFTER: small MLP amortized over simulations — scores a new dataset in 0.008 s</a:t>
+            </a:r>
+          </a:p>
+          <a:p>
+            <a:pPr>
+              <a:lnSpc>
+                <a:spcPct val="110000"/>
+              </a:lnSpc>
+              <a:spcAft>
+                <a:spcPts val="1200"/>
+              </a:spcAft>
+            </a:pPr>
+            <a:r>
+              <a:rPr sz="1600" b="1" i="0">
+                <a:solidFill>
+                  <a:srgbClr val="188038"/>
+                </a:solidFill>
+                <a:latin typeface="Calibri"/>
+              </a:rPr>
+              <a:t>•  </a:t>
+            </a:r>
+            <a:r>
+              <a:rPr sz="1600" b="0" i="0">
+                <a:solidFill>
+                  <a:srgbClr val="333333"/>
+                </a:solidFill>
+                <a:latin typeface="Calibri"/>
+              </a:rPr>
+              <a:t>Train-once cost 24.5 s pays back from the 2nd dataset onward</a:t>
+            </a:r>
+          </a:p>
+          <a:p>
+            <a:pPr>
+              <a:lnSpc>
+                <a:spcPct val="110000"/>
+              </a:lnSpc>
+              <a:spcAft>
+                <a:spcPts val="1200"/>
+              </a:spcAft>
+            </a:pPr>
+            <a:r>
+              <a:rPr sz="1600" b="1" i="0">
+                <a:solidFill>
+                  <a:srgbClr val="188038"/>
+                </a:solidFill>
+                <a:latin typeface="Calibri"/>
+              </a:rPr>
+              <a:t>•  </a:t>
+            </a:r>
+            <a:r>
+              <a:rPr sz="1600" b="0" i="0">
+                <a:solidFill>
+                  <a:srgbClr val="333333"/>
+                </a:solidFill>
+                <a:latin typeface="Calibri"/>
+              </a:rPr>
+              <a:t>Coverage parity at ≥95% nominal; amortized intervals are wider — honest sharpness/speed tradeoff</a:t>
+            </a:r>
+          </a:p>
+        </p:txBody>
+      </p:sp>
+      <p:sp>
+        <p:nvSpPr>
+          <p:cNvPr id="7" name="TextBox 6"/>
+          <p:cNvSpPr txBox="1"/>
+          <p:nvPr/>
+        </p:nvSpPr>
+        <p:spPr>
+          <a:xfrm>
+            <a:off x="640080" y="5440680"/>
+            <a:ext cx="5440680" cy="548640"/>
+          </a:xfrm>
+          <a:prstGeom prst="rect">
+            <a:avLst/>
+          </a:prstGeom>
+          <a:noFill/>
+        </p:spPr>
+        <p:txBody>
+          <a:bodyPr wrap="square">
+            <a:spAutoFit/>
+          </a:bodyPr>
+          <a:lstStyle/>
+          <a:p>
+            <a:r>
+              <a:rPr sz="1000" b="0" i="1">
+                <a:solidFill>
+                  <a:srgbClr val="9AA0A6"/>
+                </a:solidFill>
+                <a:latin typeface="Calibri"/>
+              </a:rPr>
+              <a:t>[Figure: committed result] Posterior-interval comparison (MCMC vs amortized) across datasets, plus a BEFORE/AFTER timing bar.</a:t>
+            </a:r>
+          </a:p>
+        </p:txBody>
+      </p:sp>
+      <p:sp>
+        <p:nvSpPr>
+          <p:cNvPr id="8" name="TextBox 7"/>
+          <p:cNvSpPr txBox="1"/>
+          <p:nvPr/>
+        </p:nvSpPr>
+        <p:spPr>
+          <a:xfrm>
+            <a:off x="640080" y="5989320"/>
+            <a:ext cx="10908792" cy="640080"/>
+          </a:xfrm>
+          <a:prstGeom prst="rect">
+            <a:avLst/>
+          </a:prstGeom>
+          <a:noFill/>
+        </p:spPr>
+        <p:txBody>
+          <a:bodyPr wrap="square" anchor="ctr">
+            <a:spAutoFit/>
+          </a:bodyPr>
+          <a:lstStyle/>
+          <a:p>
+            <a:r>
+              <a:rPr sz="1600" b="1" i="0">
+                <a:solidFill>
+                  <a:srgbClr val="188038"/>
+                </a:solidFill>
+                <a:latin typeface="Calibri"/>
+              </a:rPr>
+              <a:t>TAKEAWAY: ~1451× faster at scoring; same coverage; honest about wider intervals.</a:t>
             </a:r>
           </a:p>
         </p:txBody>
@@ -6772,14 +7221,14 @@
                 </a:solidFill>
                 <a:latin typeface="Calibri"/>
               </a:rPr>
-              <a:t>The flagship: an autonomous research loop — Exp05</a:t>
+              <a:t>Bonus demo: Species distribution modeling — Exp10</a:t>
             </a:r>
           </a:p>
         </p:txBody>
       </p:sp>
       <p:pic>
         <p:nvPicPr>
-          <p:cNvPr id="4" name="Picture 3" descr="champion_progress.png"/>
+          <p:cNvPr id="4" name="Picture 3" descr="suitability_map.png"/>
           <p:cNvPicPr>
             <a:picLocks noChangeAspect="1"/>
           </p:cNvPicPr>
@@ -6793,8 +7242,8 @@
         </p:blipFill>
         <p:spPr>
           <a:xfrm>
-            <a:off x="6446520" y="2150693"/>
-            <a:ext cx="5029200" cy="2922373"/>
+            <a:off x="6446520" y="2754904"/>
+            <a:ext cx="5029200" cy="1713951"/>
           </a:xfrm>
           <a:prstGeom prst="rect">
             <a:avLst/>
@@ -6847,7 +7296,7 @@
                 </a:solidFill>
                 <a:latin typeface="Calibri"/>
               </a:rPr>
-              <a:t>The agent is the researcher: Diagnose → Cite → Hypothesize → Predict → Execute → Analyze → Checkpoint</a:t>
+              <a:t>Task: predict species presence from climate + elevation covariates</a:t>
             </a:r>
           </a:p>
           <a:p>
@@ -6875,7 +7324,7 @@
                 </a:solidFill>
                 <a:latin typeface="Calibri"/>
               </a:rPr>
-              <a:t>Hard gates before any run: citation-rigor + reasoning-completeness (no ungrounded experiments)</a:t>
+              <a:t>BEFORE: logistic GLM with squared terms — AUC 0.705, Brier 0.124, suit-corr 0.696</a:t>
             </a:r>
           </a:p>
           <a:p>
@@ -6903,7 +7352,7 @@
                 </a:solidFill>
                 <a:latin typeface="Calibri"/>
               </a:rPr>
-              <a:t>Gated 6-experiment loop ran in ~38 s; champion +8.0% skill (RMSE 1.95→1.79 °C), monotone composite</a:t>
+              <a:t>AFTER: calibrated gradient boosting on the same covariates — AUC 0.728, Brier 0.122, suit-corr 0.884</a:t>
             </a:r>
           </a:p>
           <a:p>
@@ -6931,7 +7380,7 @@
                 </a:solidFill>
                 <a:latin typeface="Calibri"/>
               </a:rPr>
-              <a:t>Adapted from the user's own dlmastery/autoresearch (generalized_ml_autoresearch)</a:t>
+              <a:t>GBM recovers the elevation × climate interaction the GLM can't encode (+0.188 surface corr)</a:t>
             </a:r>
           </a:p>
           <a:p>
@@ -6959,7 +7408,7 @@
                 </a:solidFill>
                 <a:latin typeface="Calibri"/>
               </a:rPr>
-              <a:t>Pluggable backbones / splits / composite metric; champion archive + research journal; runs on one 4090</a:t>
+              <a:t>Honest caveat: GLM still safer for extrapolation outside the training envelope</a:t>
             </a:r>
           </a:p>
         </p:txBody>
@@ -6993,7 +7442,7 @@
                 </a:solidFill>
                 <a:latin typeface="Calibri"/>
               </a:rPr>
-              <a:t>[Figure: committed result] The 7-step loop as a circle with the two hard gates drawn as locks before "Execute"; a thumbnail of the champion-archive folder + research-journal entry. Reference docs/autoresearch_protocol.md.</a:t>
+              <a:t>[Figure: committed result] Predicted suitability map (BEFORE GLM vs AFTER GBM) over the synthetic landscape, with the true-suitability surface for reference.</a:t>
             </a:r>
           </a:p>
         </p:txBody>
@@ -7027,7 +7476,7 @@
                 </a:solidFill>
                 <a:latin typeface="Calibri"/>
               </a:rPr>
-              <a:t>TAKEAWAY: The loop makes the agent a researcher — gated so it can't fish for significance.</a:t>
+              <a:t>TAKEAWAY: AFTER wins on all 3 metrics; the surface gain dwarfs the AUC gain.</a:t>
             </a:r>
           </a:p>
         </p:txBody>
@@ -7046,7 +7495,7 @@
     <p:bg>
       <p:bgPr>
         <a:solidFill>
-          <a:srgbClr val="FFFFFF"/>
+          <a:srgbClr val="1A3A5C"/>
         </a:solidFill>
         <a:effectLst/>
       </p:bgPr>
@@ -7060,58 +7509,14 @@
       <p:grpSpPr/>
       <p:sp>
         <p:nvSpPr>
-          <p:cNvPr id="2" name="Rectangle 1"/>
-          <p:cNvSpPr/>
-          <p:nvPr/>
-        </p:nvSpPr>
-        <p:spPr>
-          <a:xfrm>
-            <a:off x="0" y="0"/>
-            <a:ext cx="12191695" cy="146304"/>
-          </a:xfrm>
-          <a:prstGeom prst="rect">
-            <a:avLst/>
-          </a:prstGeom>
-          <a:solidFill>
-            <a:srgbClr val="1A3A5C"/>
-          </a:solidFill>
-          <a:ln>
-            <a:noFill/>
-          </a:ln>
-          <a:effectLst/>
-        </p:spPr>
-        <p:style>
-          <a:lnRef idx="1">
-            <a:schemeClr val="accent1"/>
-          </a:lnRef>
-          <a:fillRef idx="3">
-            <a:schemeClr val="accent1"/>
-          </a:fillRef>
-          <a:effectRef idx="2">
-            <a:schemeClr val="accent1"/>
-          </a:effectRef>
-          <a:fontRef idx="minor">
-            <a:schemeClr val="lt1"/>
-          </a:fontRef>
-        </p:style>
-        <p:txBody>
-          <a:bodyPr rtlCol="0" anchor="ctr"/>
-          <a:lstStyle/>
-          <a:p>
-            <a:pPr algn="ctr"/>
-          </a:p>
-        </p:txBody>
-      </p:sp>
-      <p:sp>
-        <p:nvSpPr>
-          <p:cNvPr id="3" name="TextBox 2"/>
+          <p:cNvPr id="2" name="TextBox 1"/>
           <p:cNvSpPr txBox="1"/>
           <p:nvPr/>
         </p:nvSpPr>
         <p:spPr>
           <a:xfrm>
-            <a:off x="640080" y="292608"/>
-            <a:ext cx="10908792" cy="914400"/>
+            <a:off x="822960" y="2468880"/>
+            <a:ext cx="10515600" cy="1828800"/>
           </a:xfrm>
           <a:prstGeom prst="rect">
             <a:avLst/>
@@ -7125,244 +7530,29 @@
           <a:lstStyle/>
           <a:p>
             <a:r>
-              <a:rPr sz="2800" b="1" i="0">
-                <a:solidFill>
-                  <a:srgbClr val="1A3A5C"/>
-                </a:solidFill>
-                <a:latin typeface="Calibri"/>
-              </a:rPr>
-              <a:t>Autoresearch, honestly: what it does and doesn't do</a:t>
-            </a:r>
-          </a:p>
-        </p:txBody>
-      </p:sp>
-      <p:sp>
-        <p:nvSpPr>
-          <p:cNvPr id="4" name="TextBox 3"/>
-          <p:cNvSpPr txBox="1"/>
-          <p:nvPr/>
-        </p:nvSpPr>
-        <p:spPr>
-          <a:xfrm>
-            <a:off x="640080" y="1371600"/>
-            <a:ext cx="10908792" cy="3840480"/>
-          </a:xfrm>
-          <a:prstGeom prst="rect">
-            <a:avLst/>
-          </a:prstGeom>
-          <a:noFill/>
-        </p:spPr>
-        <p:txBody>
-          <a:bodyPr wrap="square">
-            <a:spAutoFit/>
-          </a:bodyPr>
-          <a:lstStyle/>
+              <a:rPr sz="1800" b="1" i="0">
+                <a:solidFill>
+                  <a:srgbClr val="BFD8C2"/>
+                </a:solidFill>
+                <a:latin typeface="Calibri"/>
+              </a:rPr>
+              <a:t>THE FLAGSHIP</a:t>
+            </a:r>
+          </a:p>
           <a:p>
             <a:pPr>
-              <a:lnSpc>
-                <a:spcPct val="110000"/>
-              </a:lnSpc>
-              <a:spcAft>
-                <a:spcPts val="1200"/>
-              </a:spcAft>
+              <a:spcBef>
+                <a:spcPts val="800"/>
+              </a:spcBef>
             </a:pPr>
             <a:r>
-              <a:rPr sz="1800" b="1" i="0">
-                <a:solidFill>
-                  <a:srgbClr val="188038"/>
-                </a:solidFill>
-                <a:latin typeface="Calibri"/>
-              </a:rPr>
-              <a:t>•  </a:t>
-            </a:r>
-            <a:r>
-              <a:rPr sz="1800" b="0" i="0">
-                <a:solidFill>
-                  <a:srgbClr val="333333"/>
-                </a:solidFill>
-                <a:latin typeface="Calibri"/>
-              </a:rPr>
-              <a:t>DOES: explore a defined search space fast, document every step, archive the winner</a:t>
-            </a:r>
-          </a:p>
-          <a:p>
-            <a:pPr>
-              <a:lnSpc>
-                <a:spcPct val="110000"/>
-              </a:lnSpc>
-              <a:spcAft>
-                <a:spcPts val="1200"/>
-              </a:spcAft>
-            </a:pPr>
-            <a:r>
-              <a:rPr sz="1800" b="1" i="0">
-                <a:solidFill>
-                  <a:srgbClr val="188038"/>
-                </a:solidFill>
-                <a:latin typeface="Calibri"/>
-              </a:rPr>
-              <a:t>•  </a:t>
-            </a:r>
-            <a:r>
-              <a:rPr sz="1800" b="0" i="0">
-                <a:solidFill>
-                  <a:srgbClr val="333333"/>
-                </a:solidFill>
-                <a:latin typeface="Calibri"/>
-              </a:rPr>
-              <a:t>DOESN'T: choose your scientific question, your loss, or your validity criteria — you do</a:t>
-            </a:r>
-          </a:p>
-          <a:p>
-            <a:pPr>
-              <a:lnSpc>
-                <a:spcPct val="110000"/>
-              </a:lnSpc>
-              <a:spcAft>
-                <a:spcPts val="1200"/>
-              </a:spcAft>
-            </a:pPr>
-            <a:r>
-              <a:rPr sz="1800" b="1" i="0">
-                <a:solidFill>
-                  <a:srgbClr val="188038"/>
-                </a:solidFill>
-                <a:latin typeface="Calibri"/>
-              </a:rPr>
-              <a:t>•  </a:t>
-            </a:r>
-            <a:r>
-              <a:rPr sz="1800" b="0" i="0">
-                <a:solidFill>
-                  <a:srgbClr val="333333"/>
-                </a:solidFill>
-                <a:latin typeface="Calibri"/>
-              </a:rPr>
-              <a:t>Guardrails: composite-metric fingerprint detects mid-project goal rewrites</a:t>
-            </a:r>
-          </a:p>
-          <a:p>
-            <a:pPr>
-              <a:lnSpc>
-                <a:spcPct val="110000"/>
-              </a:lnSpc>
-              <a:spcAft>
-                <a:spcPts val="1200"/>
-              </a:spcAft>
-            </a:pPr>
-            <a:r>
-              <a:rPr sz="1800" b="1" i="0">
-                <a:solidFill>
-                  <a:srgbClr val="188038"/>
-                </a:solidFill>
-                <a:latin typeface="Calibri"/>
-              </a:rPr>
-              <a:t>•  </a:t>
-            </a:r>
-            <a:r>
-              <a:rPr sz="1800" b="0" i="0">
-                <a:solidFill>
-                  <a:srgbClr val="333333"/>
-                </a:solidFill>
-                <a:latin typeface="Calibri"/>
-              </a:rPr>
-              <a:t>Reproducibility: deterministic seeds; crash-recovery checkpoints</a:t>
-            </a:r>
-          </a:p>
-          <a:p>
-            <a:pPr>
-              <a:lnSpc>
-                <a:spcPct val="110000"/>
-              </a:lnSpc>
-              <a:spcAft>
-                <a:spcPts val="1200"/>
-              </a:spcAft>
-            </a:pPr>
-            <a:r>
-              <a:rPr sz="1800" b="1" i="0">
-                <a:solidFill>
-                  <a:srgbClr val="188038"/>
-                </a:solidFill>
-                <a:latin typeface="Calibri"/>
-              </a:rPr>
-              <a:t>•  </a:t>
-            </a:r>
-            <a:r>
-              <a:rPr sz="1800" b="0" i="0">
-                <a:solidFill>
-                  <a:srgbClr val="333333"/>
-                </a:solidFill>
-                <a:latin typeface="Calibri"/>
-              </a:rPr>
-              <a:t>Output is a draft to review, not a paper to trust blindly</a:t>
-            </a:r>
-          </a:p>
-        </p:txBody>
-      </p:sp>
-      <p:sp>
-        <p:nvSpPr>
-          <p:cNvPr id="5" name="TextBox 4"/>
-          <p:cNvSpPr txBox="1"/>
-          <p:nvPr/>
-        </p:nvSpPr>
-        <p:spPr>
-          <a:xfrm>
-            <a:off x="640080" y="5349240"/>
-            <a:ext cx="10908792" cy="640080"/>
-          </a:xfrm>
-          <a:prstGeom prst="rect">
-            <a:avLst/>
-          </a:prstGeom>
-          <a:noFill/>
-        </p:spPr>
-        <p:txBody>
-          <a:bodyPr wrap="square">
-            <a:spAutoFit/>
-          </a:bodyPr>
-          <a:lstStyle/>
-          <a:p>
-            <a:r>
-              <a:rPr sz="1100" b="0" i="1">
-                <a:solidFill>
-                  <a:srgbClr val="9AA0A6"/>
-                </a:solidFill>
-                <a:latin typeface="Calibri"/>
-              </a:rPr>
-              <a:t>[Visual placeholder] A two-column "DOES / DOESN'T" card; a small lock icon for the metric-fingerprint guardrail.</a:t>
-            </a:r>
-          </a:p>
-        </p:txBody>
-      </p:sp>
-      <p:sp>
-        <p:nvSpPr>
-          <p:cNvPr id="6" name="TextBox 5"/>
-          <p:cNvSpPr txBox="1"/>
-          <p:nvPr/>
-        </p:nvSpPr>
-        <p:spPr>
-          <a:xfrm>
-            <a:off x="640080" y="5989320"/>
-            <a:ext cx="10908792" cy="640080"/>
-          </a:xfrm>
-          <a:prstGeom prst="rect">
-            <a:avLst/>
-          </a:prstGeom>
-          <a:noFill/>
-        </p:spPr>
-        <p:txBody>
-          <a:bodyPr wrap="square" anchor="ctr">
-            <a:spAutoFit/>
-          </a:bodyPr>
-          <a:lstStyle/>
-          <a:p>
-            <a:r>
-              <a:rPr sz="1600" b="1" i="0">
-                <a:solidFill>
-                  <a:srgbClr val="188038"/>
-                </a:solidFill>
-                <a:latin typeface="Calibri"/>
-              </a:rPr>
-              <a:t>TAKEAWAY: Autoresearch searches the space you define — it never defines the question.</a:t>
+              <a:rPr sz="3400" b="1" i="0">
+                <a:solidFill>
+                  <a:srgbClr val="FFFFFF"/>
+                </a:solidFill>
+                <a:latin typeface="Calibri"/>
+              </a:rPr>
+              <a:t>An autonomous research loop — Exp05</a:t>
             </a:r>
           </a:p>
         </p:txBody>
@@ -7466,21 +7656,45 @@
                 </a:solidFill>
                 <a:latin typeface="Calibri"/>
               </a:rPr>
-              <a:t>Challenges &amp; rigor: keeping the human in the loop</a:t>
-            </a:r>
-          </a:p>
-        </p:txBody>
-      </p:sp>
-      <p:sp>
-        <p:nvSpPr>
-          <p:cNvPr id="4" name="TextBox 3"/>
+              <a:t>The flagship: an autonomous research loop — Exp05</a:t>
+            </a:r>
+          </a:p>
+        </p:txBody>
+      </p:sp>
+      <p:pic>
+        <p:nvPicPr>
+          <p:cNvPr id="4" name="Picture 3" descr="champion_progress.png"/>
+          <p:cNvPicPr>
+            <a:picLocks noChangeAspect="1"/>
+          </p:cNvPicPr>
+          <p:nvPr/>
+        </p:nvPicPr>
+        <p:blipFill>
+          <a:blip r:embed="rId2"/>
+          <a:stretch>
+            <a:fillRect/>
+          </a:stretch>
+        </p:blipFill>
+        <p:spPr>
+          <a:xfrm>
+            <a:off x="6446520" y="2150693"/>
+            <a:ext cx="5029200" cy="2922373"/>
+          </a:xfrm>
+          <a:prstGeom prst="rect">
+            <a:avLst/>
+          </a:prstGeom>
+        </p:spPr>
+      </p:pic>
+      <p:sp>
+        <p:nvSpPr>
+          <p:cNvPr id="5" name="TextBox 4"/>
           <p:cNvSpPr txBox="1"/>
           <p:nvPr/>
         </p:nvSpPr>
         <p:spPr>
           <a:xfrm>
             <a:off x="640080" y="1371600"/>
-            <a:ext cx="10908792" cy="3840480"/>
+            <a:ext cx="5440680" cy="3840480"/>
           </a:xfrm>
           <a:prstGeom prst="rect">
             <a:avLst/>
@@ -7502,7 +7716,7 @@
               </a:spcAft>
             </a:pPr>
             <a:r>
-              <a:rPr sz="1800" b="1" i="0">
+              <a:rPr sz="1600" b="1" i="0">
                 <a:solidFill>
                   <a:srgbClr val="188038"/>
                 </a:solidFill>
@@ -7511,13 +7725,13 @@
               <a:t>•  </a:t>
             </a:r>
             <a:r>
-              <a:rPr sz="1800" b="0" i="0">
+              <a:rPr sz="1600" b="0" i="0">
                 <a:solidFill>
                   <a:srgbClr val="333333"/>
                 </a:solidFill>
                 <a:latin typeface="Calibri"/>
               </a:rPr>
-              <a:t>Leakage &amp; look-ahead: the most common failure — enforce chronological/spatial splits</a:t>
+              <a:t>The agent is the researcher: Diagnose → Cite → Hypothesize → Predict → Execute → Analyze → Checkpoint</a:t>
             </a:r>
           </a:p>
           <a:p>
@@ -7530,7 +7744,7 @@
               </a:spcAft>
             </a:pPr>
             <a:r>
-              <a:rPr sz="1800" b="1" i="0">
+              <a:rPr sz="1600" b="1" i="0">
                 <a:solidFill>
                   <a:srgbClr val="188038"/>
                 </a:solidFill>
@@ -7539,13 +7753,13 @@
               <a:t>•  </a:t>
             </a:r>
             <a:r>
-              <a:rPr sz="1800" b="0" i="0">
+              <a:rPr sz="1600" b="0" i="0">
                 <a:solidFill>
                   <a:srgbClr val="333333"/>
                 </a:solidFill>
                 <a:latin typeface="Calibri"/>
               </a:rPr>
-              <a:t>Multiple testing across many stations/species/cells — correct for it</a:t>
+              <a:t>Hard gates before any run: citation-rigor + reasoning-completeness (no ungrounded experiments)</a:t>
             </a:r>
           </a:p>
           <a:p>
@@ -7558,7 +7772,7 @@
               </a:spcAft>
             </a:pPr>
             <a:r>
-              <a:rPr sz="1800" b="1" i="0">
+              <a:rPr sz="1600" b="1" i="0">
                 <a:solidFill>
                   <a:srgbClr val="188038"/>
                 </a:solidFill>
@@ -7567,13 +7781,13 @@
               <a:t>•  </a:t>
             </a:r>
             <a:r>
-              <a:rPr sz="1800" b="0" i="0">
+              <a:rPr sz="1600" b="0" i="0">
                 <a:solidFill>
                   <a:srgbClr val="333333"/>
                 </a:solidFill>
                 <a:latin typeface="Calibri"/>
               </a:rPr>
-              <a:t>Uncertainty is mandatory: report intervals, not point estimates</a:t>
+              <a:t>Gated 6-experiment loop ran in ~38 s; champion +8.0% skill (RMSE 1.95→1.79 °C), monotone composite</a:t>
             </a:r>
           </a:p>
           <a:p>
@@ -7586,7 +7800,7 @@
               </a:spcAft>
             </a:pPr>
             <a:r>
-              <a:rPr sz="1800" b="1" i="0">
+              <a:rPr sz="1600" b="1" i="0">
                 <a:solidFill>
                   <a:srgbClr val="188038"/>
                 </a:solidFill>
@@ -7595,13 +7809,13 @@
               <a:t>•  </a:t>
             </a:r>
             <a:r>
-              <a:rPr sz="1800" b="0" i="0">
+              <a:rPr sz="1600" b="0" i="0">
                 <a:solidFill>
                   <a:srgbClr val="333333"/>
                 </a:solidFill>
                 <a:latin typeface="Calibri"/>
               </a:rPr>
-              <a:t>Hallucinated citations / numbers — verify; quarantine the unverified (ledgers/CITATIONS-TO-VERIFY.md)</a:t>
+              <a:t>Adapted from the user's own dlmastery/autoresearch (generalized_ml_autoresearch)</a:t>
             </a:r>
           </a:p>
           <a:p>
@@ -7614,7 +7828,7 @@
               </a:spcAft>
             </a:pPr>
             <a:r>
-              <a:rPr sz="1800" b="1" i="0">
+              <a:rPr sz="1600" b="1" i="0">
                 <a:solidFill>
                   <a:srgbClr val="188038"/>
                 </a:solidFill>
@@ -7623,27 +7837,27 @@
               <a:t>•  </a:t>
             </a:r>
             <a:r>
-              <a:rPr sz="1800" b="0" i="0">
+              <a:rPr sz="1600" b="0" i="0">
                 <a:solidFill>
                   <a:srgbClr val="333333"/>
                 </a:solidFill>
                 <a:latin typeface="Calibri"/>
               </a:rPr>
-              <a:t>Reproducibility: seeds, committed results, runs-anywhere on synthetic data</a:t>
-            </a:r>
-          </a:p>
-        </p:txBody>
-      </p:sp>
-      <p:sp>
-        <p:nvSpPr>
-          <p:cNvPr id="5" name="TextBox 4"/>
+              <a:t>Pluggable backbones / splits / composite metric; champion archive + research journal; runs on one 4090</a:t>
+            </a:r>
+          </a:p>
+        </p:txBody>
+      </p:sp>
+      <p:sp>
+        <p:nvSpPr>
+          <p:cNvPr id="6" name="TextBox 5"/>
           <p:cNvSpPr txBox="1"/>
           <p:nvPr/>
         </p:nvSpPr>
         <p:spPr>
           <a:xfrm>
-            <a:off x="640080" y="5349240"/>
-            <a:ext cx="10908792" cy="640080"/>
+            <a:off x="640080" y="5440680"/>
+            <a:ext cx="5440680" cy="548640"/>
           </a:xfrm>
           <a:prstGeom prst="rect">
             <a:avLst/>
@@ -7657,20 +7871,20 @@
           <a:lstStyle/>
           <a:p>
             <a:r>
-              <a:rPr sz="1100" b="0" i="1">
+              <a:rPr sz="1000" b="0" i="1">
                 <a:solidFill>
                   <a:srgbClr val="9AA0A6"/>
                 </a:solidFill>
                 <a:latin typeface="Calibri"/>
               </a:rPr>
-              <a:t>[Visual placeholder] A "human-in-the-loop" diagram: agent proposes → human checks the five risk items → accept/reject; the five items listed as a checklist.</a:t>
-            </a:r>
-          </a:p>
-        </p:txBody>
-      </p:sp>
-      <p:sp>
-        <p:nvSpPr>
-          <p:cNvPr id="6" name="TextBox 5"/>
+              <a:t>[Figure: committed result] The 7-step loop as a circle with the two hard gates drawn as locks before "Execute"; a thumbnail of the champion-archive folder + research-journal entry. Reference docs/autoresearch_protocol.md.</a:t>
+            </a:r>
+          </a:p>
+        </p:txBody>
+      </p:sp>
+      <p:sp>
+        <p:nvSpPr>
+          <p:cNvPr id="7" name="TextBox 6"/>
           <p:cNvSpPr txBox="1"/>
           <p:nvPr/>
         </p:nvSpPr>
@@ -7697,7 +7911,7 @@
                 </a:solidFill>
                 <a:latin typeface="Calibri"/>
               </a:rPr>
-              <a:t>TAKEAWAY: The human owns five checks — leakage, multiplicity, uncertainty, citations, reproducibility.</a:t>
+              <a:t>TAKEAWAY: The loop makes the agent a researcher — gated so it can't fish for significance.</a:t>
             </a:r>
           </a:p>
         </p:txBody>
@@ -7801,7 +8015,7 @@
                 </a:solidFill>
                 <a:latin typeface="Calibri"/>
               </a:rPr>
-              <a:t>What you can do Monday</a:t>
+              <a:t>Autoresearch, honestly: what it does and doesn't do</a:t>
             </a:r>
           </a:p>
         </p:txBody>
@@ -7852,7 +8066,7 @@
                 </a:solidFill>
                 <a:latin typeface="Calibri"/>
               </a:rPr>
-              <a:t>Today: install Claude Code; ask it to reproduce one figure from your last paper</a:t>
+              <a:t>DOES: explore a defined search space fast, document every step, archive the winner</a:t>
             </a:r>
           </a:p>
           <a:p>
@@ -7880,7 +8094,7 @@
                 </a:solidFill>
                 <a:latin typeface="Calibri"/>
               </a:rPr>
-              <a:t>This week: hand it a full small pipeline — "fetch ERA5, fit a trend, validate, plot"</a:t>
+              <a:t>DOESN'T: choose your scientific question, your loss, or your validity criteria — you do</a:t>
             </a:r>
           </a:p>
           <a:p>
@@ -7908,7 +8122,7 @@
                 </a:solidFill>
                 <a:latin typeface="Calibri"/>
               </a:rPr>
-              <a:t>This month: write one skill that encodes your group's validation conventions</a:t>
+              <a:t>Guardrails: composite-metric fingerprint detects mid-project goal rewrites</a:t>
             </a:r>
           </a:p>
           <a:p>
@@ -7936,7 +8150,7 @@
                 </a:solidFill>
                 <a:latin typeface="Calibri"/>
               </a:rPr>
-              <a:t>Start on synthetic / small public data — no keys, no GPU — then scale up</a:t>
+              <a:t>Reproducibility: deterministic seeds; crash-recovery checkpoints</a:t>
             </a:r>
           </a:p>
           <a:p>
@@ -7964,7 +8178,7 @@
                 </a:solidFill>
                 <a:latin typeface="Calibri"/>
               </a:rPr>
-              <a:t>Clone this repo and run experiments/01_.../run_before_after.py as your template</a:t>
+              <a:t>Output is a draft to review, not a paper to trust blindly</a:t>
             </a:r>
           </a:p>
         </p:txBody>
@@ -7998,7 +8212,7 @@
                 </a:solidFill>
                 <a:latin typeface="Calibri"/>
               </a:rPr>
-              <a:t>[Visual placeholder] A three-step "Today / This week / This month" timeline card mirroring the handout; a small QR placeholder to the repo.</a:t>
+              <a:t>[Visual placeholder] A two-column "DOES / DOESN'T" card; a small lock icon for the metric-fingerprint guardrail.</a:t>
             </a:r>
           </a:p>
         </p:txBody>
@@ -8032,7 +8246,7 @@
                 </a:solidFill>
                 <a:latin typeface="Calibri"/>
               </a:rPr>
-              <a:t>TAKEAWAY: You can start today on synthetic data — no keys, no GPU required.</a:t>
+              <a:t>TAKEAWAY: Autoresearch searches the space you define — it never defines the question.</a:t>
             </a:r>
           </a:p>
         </p:txBody>
@@ -8136,7 +8350,7 @@
                 </a:solidFill>
                 <a:latin typeface="Calibri"/>
               </a:rPr>
-              <a:t>Vision: the 100×-faster lab</a:t>
+              <a:t>Challenges &amp; rigor: keeping the human in the loop</a:t>
             </a:r>
           </a:p>
         </p:txBody>
@@ -8187,7 +8401,7 @@
                 </a:solidFill>
                 <a:latin typeface="Calibri"/>
               </a:rPr>
-              <a:t>The scarce resource becomes good questions and good judgment, not labor</a:t>
+              <a:t>Leakage &amp; look-ahead: the most common failure — enforce chronological/spatial splits</a:t>
             </a:r>
           </a:p>
           <a:p>
@@ -8215,7 +8429,7 @@
                 </a:solidFill>
                 <a:latin typeface="Calibri"/>
               </a:rPr>
-              <a:t>Each scientist runs a small team of agents; reproducibility and audit trails improve, not degrade</a:t>
+              <a:t>Multiple testing across many stations/species/cells — correct for it</a:t>
             </a:r>
           </a:p>
           <a:p>
@@ -8243,7 +8457,7 @@
                 </a:solidFill>
                 <a:latin typeface="Calibri"/>
               </a:rPr>
-              <a:t>Open data + desktop GPUs + agents → individual scientists doing institution-scale work</a:t>
+              <a:t>Uncertainty is mandatory: report intervals, not point estimates</a:t>
             </a:r>
           </a:p>
           <a:p>
@@ -8271,7 +8485,7 @@
                 </a:solidFill>
                 <a:latin typeface="Calibri"/>
               </a:rPr>
-              <a:t>The statistician's role grows: assumptions, validity, interpretation, communication</a:t>
+              <a:t>Hallucinated citations / numbers — verify; quarantine the unverified (ledgers/CITATIONS-TO-VERIFY.md)</a:t>
             </a:r>
           </a:p>
           <a:p>
@@ -8299,7 +8513,7 @@
                 </a:solidFill>
                 <a:latin typeface="Calibri"/>
               </a:rPr>
-              <a:t>The repo is the proof-of-concept; your lab is the next instance</a:t>
+              <a:t>Reproducibility: seeds, committed results, runs-anywhere on synthetic data</a:t>
             </a:r>
           </a:p>
         </p:txBody>
@@ -8333,7 +8547,7 @@
                 </a:solidFill>
                 <a:latin typeface="Calibri"/>
               </a:rPr>
-              <a:t>[Visual placeholder] A single scientist at a laptop with several "agent" worker icons fanning out to the taxonomy cells; calm, optimistic framing.</a:t>
+              <a:t>[Visual placeholder] A "human-in-the-loop" diagram: agent proposes → human checks the five risk items → accept/reject; the five items listed as a checklist.</a:t>
             </a:r>
           </a:p>
         </p:txBody>
@@ -8367,7 +8581,7 @@
                 </a:solidFill>
                 <a:latin typeface="Calibri"/>
               </a:rPr>
-              <a:t>TAKEAWAY: When labor is cheap, scientific judgment becomes the differentiator.</a:t>
+              <a:t>TAKEAWAY: The human owns five checks — leakage, multiplicity, uncertainty, citations, reproducibility.</a:t>
             </a:r>
           </a:p>
         </p:txBody>
@@ -8716,6 +8930,676 @@
 </file>
 
 <file path=ppt/slides/slide20.xml><?xml version="1.0" encoding="utf-8"?>
+<p:sld xmlns:a="http://schemas.openxmlformats.org/drawingml/2006/main" xmlns:p="http://schemas.openxmlformats.org/presentationml/2006/main" xmlns:r="http://schemas.openxmlformats.org/officeDocument/2006/relationships">
+  <p:cSld>
+    <p:bg>
+      <p:bgPr>
+        <a:solidFill>
+          <a:srgbClr val="FFFFFF"/>
+        </a:solidFill>
+        <a:effectLst/>
+      </p:bgPr>
+    </p:bg>
+    <p:spTree>
+      <p:nvGrpSpPr>
+        <p:cNvPr id="1" name=""/>
+        <p:cNvGrpSpPr/>
+        <p:nvPr/>
+      </p:nvGrpSpPr>
+      <p:grpSpPr/>
+      <p:sp>
+        <p:nvSpPr>
+          <p:cNvPr id="2" name="Rectangle 1"/>
+          <p:cNvSpPr/>
+          <p:nvPr/>
+        </p:nvSpPr>
+        <p:spPr>
+          <a:xfrm>
+            <a:off x="0" y="0"/>
+            <a:ext cx="12191695" cy="146304"/>
+          </a:xfrm>
+          <a:prstGeom prst="rect">
+            <a:avLst/>
+          </a:prstGeom>
+          <a:solidFill>
+            <a:srgbClr val="1A3A5C"/>
+          </a:solidFill>
+          <a:ln>
+            <a:noFill/>
+          </a:ln>
+          <a:effectLst/>
+        </p:spPr>
+        <p:style>
+          <a:lnRef idx="1">
+            <a:schemeClr val="accent1"/>
+          </a:lnRef>
+          <a:fillRef idx="3">
+            <a:schemeClr val="accent1"/>
+          </a:fillRef>
+          <a:effectRef idx="2">
+            <a:schemeClr val="accent1"/>
+          </a:effectRef>
+          <a:fontRef idx="minor">
+            <a:schemeClr val="lt1"/>
+          </a:fontRef>
+        </p:style>
+        <p:txBody>
+          <a:bodyPr rtlCol="0" anchor="ctr"/>
+          <a:lstStyle/>
+          <a:p>
+            <a:pPr algn="ctr"/>
+          </a:p>
+        </p:txBody>
+      </p:sp>
+      <p:sp>
+        <p:nvSpPr>
+          <p:cNvPr id="3" name="TextBox 2"/>
+          <p:cNvSpPr txBox="1"/>
+          <p:nvPr/>
+        </p:nvSpPr>
+        <p:spPr>
+          <a:xfrm>
+            <a:off x="640080" y="292608"/>
+            <a:ext cx="10908792" cy="914400"/>
+          </a:xfrm>
+          <a:prstGeom prst="rect">
+            <a:avLst/>
+          </a:prstGeom>
+          <a:noFill/>
+        </p:spPr>
+        <p:txBody>
+          <a:bodyPr wrap="square">
+            <a:spAutoFit/>
+          </a:bodyPr>
+          <a:lstStyle/>
+          <a:p>
+            <a:r>
+              <a:rPr sz="2800" b="1" i="0">
+                <a:solidFill>
+                  <a:srgbClr val="1A3A5C"/>
+                </a:solidFill>
+                <a:latin typeface="Calibri"/>
+              </a:rPr>
+              <a:t>What you can do Monday</a:t>
+            </a:r>
+          </a:p>
+        </p:txBody>
+      </p:sp>
+      <p:sp>
+        <p:nvSpPr>
+          <p:cNvPr id="4" name="TextBox 3"/>
+          <p:cNvSpPr txBox="1"/>
+          <p:nvPr/>
+        </p:nvSpPr>
+        <p:spPr>
+          <a:xfrm>
+            <a:off x="640080" y="1371600"/>
+            <a:ext cx="10908792" cy="3840480"/>
+          </a:xfrm>
+          <a:prstGeom prst="rect">
+            <a:avLst/>
+          </a:prstGeom>
+          <a:noFill/>
+        </p:spPr>
+        <p:txBody>
+          <a:bodyPr wrap="square">
+            <a:spAutoFit/>
+          </a:bodyPr>
+          <a:lstStyle/>
+          <a:p>
+            <a:pPr>
+              <a:lnSpc>
+                <a:spcPct val="110000"/>
+              </a:lnSpc>
+              <a:spcAft>
+                <a:spcPts val="1200"/>
+              </a:spcAft>
+            </a:pPr>
+            <a:r>
+              <a:rPr sz="1800" b="1" i="0">
+                <a:solidFill>
+                  <a:srgbClr val="188038"/>
+                </a:solidFill>
+                <a:latin typeface="Calibri"/>
+              </a:rPr>
+              <a:t>•  </a:t>
+            </a:r>
+            <a:r>
+              <a:rPr sz="1800" b="0" i="0">
+                <a:solidFill>
+                  <a:srgbClr val="333333"/>
+                </a:solidFill>
+                <a:latin typeface="Calibri"/>
+              </a:rPr>
+              <a:t>Today: install Claude Code; ask it to reproduce one figure from your last paper</a:t>
+            </a:r>
+          </a:p>
+          <a:p>
+            <a:pPr>
+              <a:lnSpc>
+                <a:spcPct val="110000"/>
+              </a:lnSpc>
+              <a:spcAft>
+                <a:spcPts val="1200"/>
+              </a:spcAft>
+            </a:pPr>
+            <a:r>
+              <a:rPr sz="1800" b="1" i="0">
+                <a:solidFill>
+                  <a:srgbClr val="188038"/>
+                </a:solidFill>
+                <a:latin typeface="Calibri"/>
+              </a:rPr>
+              <a:t>•  </a:t>
+            </a:r>
+            <a:r>
+              <a:rPr sz="1800" b="0" i="0">
+                <a:solidFill>
+                  <a:srgbClr val="333333"/>
+                </a:solidFill>
+                <a:latin typeface="Calibri"/>
+              </a:rPr>
+              <a:t>This week: hand it a full small pipeline — "fetch ERA5, fit a trend, validate, plot"</a:t>
+            </a:r>
+          </a:p>
+          <a:p>
+            <a:pPr>
+              <a:lnSpc>
+                <a:spcPct val="110000"/>
+              </a:lnSpc>
+              <a:spcAft>
+                <a:spcPts val="1200"/>
+              </a:spcAft>
+            </a:pPr>
+            <a:r>
+              <a:rPr sz="1800" b="1" i="0">
+                <a:solidFill>
+                  <a:srgbClr val="188038"/>
+                </a:solidFill>
+                <a:latin typeface="Calibri"/>
+              </a:rPr>
+              <a:t>•  </a:t>
+            </a:r>
+            <a:r>
+              <a:rPr sz="1800" b="0" i="0">
+                <a:solidFill>
+                  <a:srgbClr val="333333"/>
+                </a:solidFill>
+                <a:latin typeface="Calibri"/>
+              </a:rPr>
+              <a:t>This month: write one skill that encodes your group's validation conventions</a:t>
+            </a:r>
+          </a:p>
+          <a:p>
+            <a:pPr>
+              <a:lnSpc>
+                <a:spcPct val="110000"/>
+              </a:lnSpc>
+              <a:spcAft>
+                <a:spcPts val="1200"/>
+              </a:spcAft>
+            </a:pPr>
+            <a:r>
+              <a:rPr sz="1800" b="1" i="0">
+                <a:solidFill>
+                  <a:srgbClr val="188038"/>
+                </a:solidFill>
+                <a:latin typeface="Calibri"/>
+              </a:rPr>
+              <a:t>•  </a:t>
+            </a:r>
+            <a:r>
+              <a:rPr sz="1800" b="0" i="0">
+                <a:solidFill>
+                  <a:srgbClr val="333333"/>
+                </a:solidFill>
+                <a:latin typeface="Calibri"/>
+              </a:rPr>
+              <a:t>Start on synthetic / small public data — no keys, no GPU — then scale up</a:t>
+            </a:r>
+          </a:p>
+          <a:p>
+            <a:pPr>
+              <a:lnSpc>
+                <a:spcPct val="110000"/>
+              </a:lnSpc>
+              <a:spcAft>
+                <a:spcPts val="1200"/>
+              </a:spcAft>
+            </a:pPr>
+            <a:r>
+              <a:rPr sz="1800" b="1" i="0">
+                <a:solidFill>
+                  <a:srgbClr val="188038"/>
+                </a:solidFill>
+                <a:latin typeface="Calibri"/>
+              </a:rPr>
+              <a:t>•  </a:t>
+            </a:r>
+            <a:r>
+              <a:rPr sz="1800" b="0" i="0">
+                <a:solidFill>
+                  <a:srgbClr val="333333"/>
+                </a:solidFill>
+                <a:latin typeface="Calibri"/>
+              </a:rPr>
+              <a:t>Clone this repo and run experiments/01_.../run_before_after.py as your template</a:t>
+            </a:r>
+          </a:p>
+        </p:txBody>
+      </p:sp>
+      <p:sp>
+        <p:nvSpPr>
+          <p:cNvPr id="5" name="TextBox 4"/>
+          <p:cNvSpPr txBox="1"/>
+          <p:nvPr/>
+        </p:nvSpPr>
+        <p:spPr>
+          <a:xfrm>
+            <a:off x="640080" y="5349240"/>
+            <a:ext cx="10908792" cy="640080"/>
+          </a:xfrm>
+          <a:prstGeom prst="rect">
+            <a:avLst/>
+          </a:prstGeom>
+          <a:noFill/>
+        </p:spPr>
+        <p:txBody>
+          <a:bodyPr wrap="square">
+            <a:spAutoFit/>
+          </a:bodyPr>
+          <a:lstStyle/>
+          <a:p>
+            <a:r>
+              <a:rPr sz="1100" b="0" i="1">
+                <a:solidFill>
+                  <a:srgbClr val="9AA0A6"/>
+                </a:solidFill>
+                <a:latin typeface="Calibri"/>
+              </a:rPr>
+              <a:t>[Visual placeholder] A three-step "Today / This week / This month" timeline card mirroring the handout; a small QR placeholder to the repo.</a:t>
+            </a:r>
+          </a:p>
+        </p:txBody>
+      </p:sp>
+      <p:sp>
+        <p:nvSpPr>
+          <p:cNvPr id="6" name="TextBox 5"/>
+          <p:cNvSpPr txBox="1"/>
+          <p:nvPr/>
+        </p:nvSpPr>
+        <p:spPr>
+          <a:xfrm>
+            <a:off x="640080" y="5989320"/>
+            <a:ext cx="10908792" cy="640080"/>
+          </a:xfrm>
+          <a:prstGeom prst="rect">
+            <a:avLst/>
+          </a:prstGeom>
+          <a:noFill/>
+        </p:spPr>
+        <p:txBody>
+          <a:bodyPr wrap="square" anchor="ctr">
+            <a:spAutoFit/>
+          </a:bodyPr>
+          <a:lstStyle/>
+          <a:p>
+            <a:r>
+              <a:rPr sz="1600" b="1" i="0">
+                <a:solidFill>
+                  <a:srgbClr val="188038"/>
+                </a:solidFill>
+                <a:latin typeface="Calibri"/>
+              </a:rPr>
+              <a:t>TAKEAWAY: You can start today on synthetic data — no keys, no GPU required.</a:t>
+            </a:r>
+          </a:p>
+        </p:txBody>
+      </p:sp>
+    </p:spTree>
+  </p:cSld>
+  <p:clrMapOvr>
+    <a:masterClrMapping/>
+  </p:clrMapOvr>
+</p:sld>
+</file>
+
+<file path=ppt/slides/slide21.xml><?xml version="1.0" encoding="utf-8"?>
+<p:sld xmlns:a="http://schemas.openxmlformats.org/drawingml/2006/main" xmlns:p="http://schemas.openxmlformats.org/presentationml/2006/main" xmlns:r="http://schemas.openxmlformats.org/officeDocument/2006/relationships">
+  <p:cSld>
+    <p:bg>
+      <p:bgPr>
+        <a:solidFill>
+          <a:srgbClr val="FFFFFF"/>
+        </a:solidFill>
+        <a:effectLst/>
+      </p:bgPr>
+    </p:bg>
+    <p:spTree>
+      <p:nvGrpSpPr>
+        <p:cNvPr id="1" name=""/>
+        <p:cNvGrpSpPr/>
+        <p:nvPr/>
+      </p:nvGrpSpPr>
+      <p:grpSpPr/>
+      <p:sp>
+        <p:nvSpPr>
+          <p:cNvPr id="2" name="Rectangle 1"/>
+          <p:cNvSpPr/>
+          <p:nvPr/>
+        </p:nvSpPr>
+        <p:spPr>
+          <a:xfrm>
+            <a:off x="0" y="0"/>
+            <a:ext cx="12191695" cy="146304"/>
+          </a:xfrm>
+          <a:prstGeom prst="rect">
+            <a:avLst/>
+          </a:prstGeom>
+          <a:solidFill>
+            <a:srgbClr val="1A3A5C"/>
+          </a:solidFill>
+          <a:ln>
+            <a:noFill/>
+          </a:ln>
+          <a:effectLst/>
+        </p:spPr>
+        <p:style>
+          <a:lnRef idx="1">
+            <a:schemeClr val="accent1"/>
+          </a:lnRef>
+          <a:fillRef idx="3">
+            <a:schemeClr val="accent1"/>
+          </a:fillRef>
+          <a:effectRef idx="2">
+            <a:schemeClr val="accent1"/>
+          </a:effectRef>
+          <a:fontRef idx="minor">
+            <a:schemeClr val="lt1"/>
+          </a:fontRef>
+        </p:style>
+        <p:txBody>
+          <a:bodyPr rtlCol="0" anchor="ctr"/>
+          <a:lstStyle/>
+          <a:p>
+            <a:pPr algn="ctr"/>
+          </a:p>
+        </p:txBody>
+      </p:sp>
+      <p:sp>
+        <p:nvSpPr>
+          <p:cNvPr id="3" name="TextBox 2"/>
+          <p:cNvSpPr txBox="1"/>
+          <p:nvPr/>
+        </p:nvSpPr>
+        <p:spPr>
+          <a:xfrm>
+            <a:off x="640080" y="292608"/>
+            <a:ext cx="10908792" cy="914400"/>
+          </a:xfrm>
+          <a:prstGeom prst="rect">
+            <a:avLst/>
+          </a:prstGeom>
+          <a:noFill/>
+        </p:spPr>
+        <p:txBody>
+          <a:bodyPr wrap="square">
+            <a:spAutoFit/>
+          </a:bodyPr>
+          <a:lstStyle/>
+          <a:p>
+            <a:r>
+              <a:rPr sz="2800" b="1" i="0">
+                <a:solidFill>
+                  <a:srgbClr val="1A3A5C"/>
+                </a:solidFill>
+                <a:latin typeface="Calibri"/>
+              </a:rPr>
+              <a:t>Vision: the 100×-faster lab</a:t>
+            </a:r>
+          </a:p>
+        </p:txBody>
+      </p:sp>
+      <p:sp>
+        <p:nvSpPr>
+          <p:cNvPr id="4" name="TextBox 3"/>
+          <p:cNvSpPr txBox="1"/>
+          <p:nvPr/>
+        </p:nvSpPr>
+        <p:spPr>
+          <a:xfrm>
+            <a:off x="640080" y="1371600"/>
+            <a:ext cx="10908792" cy="3840480"/>
+          </a:xfrm>
+          <a:prstGeom prst="rect">
+            <a:avLst/>
+          </a:prstGeom>
+          <a:noFill/>
+        </p:spPr>
+        <p:txBody>
+          <a:bodyPr wrap="square">
+            <a:spAutoFit/>
+          </a:bodyPr>
+          <a:lstStyle/>
+          <a:p>
+            <a:pPr>
+              <a:lnSpc>
+                <a:spcPct val="110000"/>
+              </a:lnSpc>
+              <a:spcAft>
+                <a:spcPts val="1200"/>
+              </a:spcAft>
+            </a:pPr>
+            <a:r>
+              <a:rPr sz="1800" b="1" i="0">
+                <a:solidFill>
+                  <a:srgbClr val="188038"/>
+                </a:solidFill>
+                <a:latin typeface="Calibri"/>
+              </a:rPr>
+              <a:t>•  </a:t>
+            </a:r>
+            <a:r>
+              <a:rPr sz="1800" b="0" i="0">
+                <a:solidFill>
+                  <a:srgbClr val="333333"/>
+                </a:solidFill>
+                <a:latin typeface="Calibri"/>
+              </a:rPr>
+              <a:t>The scarce resource becomes good questions and good judgment, not labor</a:t>
+            </a:r>
+          </a:p>
+          <a:p>
+            <a:pPr>
+              <a:lnSpc>
+                <a:spcPct val="110000"/>
+              </a:lnSpc>
+              <a:spcAft>
+                <a:spcPts val="1200"/>
+              </a:spcAft>
+            </a:pPr>
+            <a:r>
+              <a:rPr sz="1800" b="1" i="0">
+                <a:solidFill>
+                  <a:srgbClr val="188038"/>
+                </a:solidFill>
+                <a:latin typeface="Calibri"/>
+              </a:rPr>
+              <a:t>•  </a:t>
+            </a:r>
+            <a:r>
+              <a:rPr sz="1800" b="0" i="0">
+                <a:solidFill>
+                  <a:srgbClr val="333333"/>
+                </a:solidFill>
+                <a:latin typeface="Calibri"/>
+              </a:rPr>
+              <a:t>Each scientist runs a small team of agents; reproducibility and audit trails improve, not degrade</a:t>
+            </a:r>
+          </a:p>
+          <a:p>
+            <a:pPr>
+              <a:lnSpc>
+                <a:spcPct val="110000"/>
+              </a:lnSpc>
+              <a:spcAft>
+                <a:spcPts val="1200"/>
+              </a:spcAft>
+            </a:pPr>
+            <a:r>
+              <a:rPr sz="1800" b="1" i="0">
+                <a:solidFill>
+                  <a:srgbClr val="188038"/>
+                </a:solidFill>
+                <a:latin typeface="Calibri"/>
+              </a:rPr>
+              <a:t>•  </a:t>
+            </a:r>
+            <a:r>
+              <a:rPr sz="1800" b="0" i="0">
+                <a:solidFill>
+                  <a:srgbClr val="333333"/>
+                </a:solidFill>
+                <a:latin typeface="Calibri"/>
+              </a:rPr>
+              <a:t>Open data + desktop GPUs + agents → individual scientists doing institution-scale work</a:t>
+            </a:r>
+          </a:p>
+          <a:p>
+            <a:pPr>
+              <a:lnSpc>
+                <a:spcPct val="110000"/>
+              </a:lnSpc>
+              <a:spcAft>
+                <a:spcPts val="1200"/>
+              </a:spcAft>
+            </a:pPr>
+            <a:r>
+              <a:rPr sz="1800" b="1" i="0">
+                <a:solidFill>
+                  <a:srgbClr val="188038"/>
+                </a:solidFill>
+                <a:latin typeface="Calibri"/>
+              </a:rPr>
+              <a:t>•  </a:t>
+            </a:r>
+            <a:r>
+              <a:rPr sz="1800" b="0" i="0">
+                <a:solidFill>
+                  <a:srgbClr val="333333"/>
+                </a:solidFill>
+                <a:latin typeface="Calibri"/>
+              </a:rPr>
+              <a:t>The statistician's role grows: assumptions, validity, interpretation, communication</a:t>
+            </a:r>
+          </a:p>
+          <a:p>
+            <a:pPr>
+              <a:lnSpc>
+                <a:spcPct val="110000"/>
+              </a:lnSpc>
+              <a:spcAft>
+                <a:spcPts val="1200"/>
+              </a:spcAft>
+            </a:pPr>
+            <a:r>
+              <a:rPr sz="1800" b="1" i="0">
+                <a:solidFill>
+                  <a:srgbClr val="188038"/>
+                </a:solidFill>
+                <a:latin typeface="Calibri"/>
+              </a:rPr>
+              <a:t>•  </a:t>
+            </a:r>
+            <a:r>
+              <a:rPr sz="1800" b="0" i="0">
+                <a:solidFill>
+                  <a:srgbClr val="333333"/>
+                </a:solidFill>
+                <a:latin typeface="Calibri"/>
+              </a:rPr>
+              <a:t>The repo is the proof-of-concept; your lab is the next instance</a:t>
+            </a:r>
+          </a:p>
+        </p:txBody>
+      </p:sp>
+      <p:sp>
+        <p:nvSpPr>
+          <p:cNvPr id="5" name="TextBox 4"/>
+          <p:cNvSpPr txBox="1"/>
+          <p:nvPr/>
+        </p:nvSpPr>
+        <p:spPr>
+          <a:xfrm>
+            <a:off x="640080" y="5349240"/>
+            <a:ext cx="10908792" cy="640080"/>
+          </a:xfrm>
+          <a:prstGeom prst="rect">
+            <a:avLst/>
+          </a:prstGeom>
+          <a:noFill/>
+        </p:spPr>
+        <p:txBody>
+          <a:bodyPr wrap="square">
+            <a:spAutoFit/>
+          </a:bodyPr>
+          <a:lstStyle/>
+          <a:p>
+            <a:r>
+              <a:rPr sz="1100" b="0" i="1">
+                <a:solidFill>
+                  <a:srgbClr val="9AA0A6"/>
+                </a:solidFill>
+                <a:latin typeface="Calibri"/>
+              </a:rPr>
+              <a:t>[Visual placeholder] A single scientist at a laptop with several "agent" worker icons fanning out to the taxonomy cells; calm, optimistic framing.</a:t>
+            </a:r>
+          </a:p>
+        </p:txBody>
+      </p:sp>
+      <p:sp>
+        <p:nvSpPr>
+          <p:cNvPr id="6" name="TextBox 5"/>
+          <p:cNvSpPr txBox="1"/>
+          <p:nvPr/>
+        </p:nvSpPr>
+        <p:spPr>
+          <a:xfrm>
+            <a:off x="640080" y="5989320"/>
+            <a:ext cx="10908792" cy="640080"/>
+          </a:xfrm>
+          <a:prstGeom prst="rect">
+            <a:avLst/>
+          </a:prstGeom>
+          <a:noFill/>
+        </p:spPr>
+        <p:txBody>
+          <a:bodyPr wrap="square" anchor="ctr">
+            <a:spAutoFit/>
+          </a:bodyPr>
+          <a:lstStyle/>
+          <a:p>
+            <a:r>
+              <a:rPr sz="1600" b="1" i="0">
+                <a:solidFill>
+                  <a:srgbClr val="188038"/>
+                </a:solidFill>
+                <a:latin typeface="Calibri"/>
+              </a:rPr>
+              <a:t>TAKEAWAY: When labor is cheap, scientific judgment becomes the differentiator.</a:t>
+            </a:r>
+          </a:p>
+        </p:txBody>
+      </p:sp>
+    </p:spTree>
+  </p:cSld>
+  <p:clrMapOvr>
+    <a:masterClrMapping/>
+  </p:clrMapOvr>
+</p:sld>
+</file>
+
+<file path=ppt/slides/slide22.xml><?xml version="1.0" encoding="utf-8"?>
 <p:sld xmlns:a="http://schemas.openxmlformats.org/drawingml/2006/main" xmlns:p="http://schemas.openxmlformats.org/presentationml/2006/main" xmlns:r="http://schemas.openxmlformats.org/officeDocument/2006/relationships">
   <p:cSld>
     <p:bg>

</xml_diff>